<commit_message>
chore(presentation): re-export pdf, pptx and html bundle
Regenerate the printed PDF (18 pages, footer on content slides), the PPTX (26 slides with the build-in steps) and the HTML bundle from the redesigned deck.
</commit_message>
<xml_diff>
--- a/presentation/slides.pptx
+++ b/presentation/slides.pptx
@@ -26,9 +26,14 @@
     <p:sldId id="274" r:id="rId20"/>
     <p:sldId id="275" r:id="rId21"/>
     <p:sldId id="276" r:id="rId22"/>
+    <p:sldId id="277" r:id="rId23"/>
+    <p:sldId id="278" r:id="rId24"/>
+    <p:sldId id="279" r:id="rId25"/>
+    <p:sldId id="280" r:id="rId26"/>
+    <p:sldId id="281" r:id="rId27"/>
   </p:sldIdLst>
   <p:notesMasterIdLst>
-    <p:notesMasterId r:id="rId23"/>
+    <p:notesMasterId r:id="rId28"/>
   </p:notesMasterIdLst>
   <p:sldSz cx="9334500" cy="5248275"/>
   <p:notesSz cx="5248275" cy="9334500"/>
@@ -1690,6 +1695,446 @@
             <a:fld id="{F7021451-1387-4CA6-816F-3879F97B5CBC}" type="slidenum">
               <a:rPr lang="en-US"/>
               <a:t>21</a:t>
+            </a:fld>
+            <a:endParaRPr lang="en-US"/>
+          </a:p>
+        </p:txBody>
+      </p:sp>
+    </p:spTree>
+    <p:extLst>
+      <p:ext uri="{BB962C8B-B14F-4D97-AF65-F5344CB8AC3E}">
+        <p14:creationId xmlns:p14="http://schemas.microsoft.com/office/powerpoint/2010/main" val="1024086991"/>
+      </p:ext>
+    </p:extLst>
+  </p:cSld>
+  <p:clrMapOvr>
+    <a:masterClrMapping/>
+  </p:clrMapOvr>
+</p:notes>
+</file>
+
+<file path=ppt/notesSlides/notesSlide22.xml><?xml version="1.0" encoding="utf-8"?>
+<p:notes xmlns:a="http://schemas.openxmlformats.org/drawingml/2006/main" xmlns:r="http://schemas.openxmlformats.org/officeDocument/2006/relationships" xmlns:p="http://schemas.openxmlformats.org/presentationml/2006/main">
+  <p:cSld>
+    <p:spTree>
+      <p:nvGrpSpPr>
+        <p:cNvPr id="1" name=""/>
+        <p:cNvGrpSpPr/>
+        <p:nvPr/>
+      </p:nvGrpSpPr>
+      <p:grpSpPr>
+        <a:xfrm>
+          <a:off x="0" y="0"/>
+          <a:ext cx="0" cy="0"/>
+          <a:chOff x="0" y="0"/>
+          <a:chExt cx="0" cy="0"/>
+        </a:xfrm>
+      </p:grpSpPr>
+      <p:sp>
+        <p:nvSpPr>
+          <p:cNvPr id="2" name="Slide Image Placeholder 1"/>
+          <p:cNvSpPr>
+            <a:spLocks noGrp="1" noRot="1" noChangeAspect="1"/>
+          </p:cNvSpPr>
+          <p:nvPr>
+            <p:ph type="sldImg"/>
+          </p:nvPr>
+        </p:nvSpPr>
+        <p:spPr/>
+      </p:sp>
+      <p:sp>
+        <p:nvSpPr>
+          <p:cNvPr id="3" name="Notes Placeholder 2"/>
+          <p:cNvSpPr>
+            <a:spLocks noGrp="1"/>
+          </p:cNvSpPr>
+          <p:nvPr>
+            <p:ph type="body" idx="1"/>
+          </p:nvPr>
+        </p:nvSpPr>
+        <p:spPr/>
+        <p:txBody>
+          <a:bodyPr/>
+          <a:lstStyle/>
+          <a:p>
+            <a:r>
+              <a:rPr lang="en-US" dirty="0"/>
+              <a:t/>
+            </a:r>
+            <a:endParaRPr lang="en-US" dirty="0"/>
+          </a:p>
+        </p:txBody>
+      </p:sp>
+      <p:sp>
+        <p:nvSpPr>
+          <p:cNvPr id="4" name="Slide Number Placeholder 3"/>
+          <p:cNvSpPr>
+            <a:spLocks noGrp="1"/>
+          </p:cNvSpPr>
+          <p:nvPr>
+            <p:ph type="sldNum" sz="quarter" idx="10"/>
+          </p:nvPr>
+        </p:nvSpPr>
+        <p:spPr/>
+        <p:txBody>
+          <a:bodyPr/>
+          <a:lstStyle/>
+          <a:p>
+            <a:fld id="{F7021451-1387-4CA6-816F-3879F97B5CBC}" type="slidenum">
+              <a:rPr lang="en-US"/>
+              <a:t>22</a:t>
+            </a:fld>
+            <a:endParaRPr lang="en-US"/>
+          </a:p>
+        </p:txBody>
+      </p:sp>
+    </p:spTree>
+    <p:extLst>
+      <p:ext uri="{BB962C8B-B14F-4D97-AF65-F5344CB8AC3E}">
+        <p14:creationId xmlns:p14="http://schemas.microsoft.com/office/powerpoint/2010/main" val="1024086991"/>
+      </p:ext>
+    </p:extLst>
+  </p:cSld>
+  <p:clrMapOvr>
+    <a:masterClrMapping/>
+  </p:clrMapOvr>
+</p:notes>
+</file>
+
+<file path=ppt/notesSlides/notesSlide23.xml><?xml version="1.0" encoding="utf-8"?>
+<p:notes xmlns:a="http://schemas.openxmlformats.org/drawingml/2006/main" xmlns:r="http://schemas.openxmlformats.org/officeDocument/2006/relationships" xmlns:p="http://schemas.openxmlformats.org/presentationml/2006/main">
+  <p:cSld>
+    <p:spTree>
+      <p:nvGrpSpPr>
+        <p:cNvPr id="1" name=""/>
+        <p:cNvGrpSpPr/>
+        <p:nvPr/>
+      </p:nvGrpSpPr>
+      <p:grpSpPr>
+        <a:xfrm>
+          <a:off x="0" y="0"/>
+          <a:ext cx="0" cy="0"/>
+          <a:chOff x="0" y="0"/>
+          <a:chExt cx="0" cy="0"/>
+        </a:xfrm>
+      </p:grpSpPr>
+      <p:sp>
+        <p:nvSpPr>
+          <p:cNvPr id="2" name="Slide Image Placeholder 1"/>
+          <p:cNvSpPr>
+            <a:spLocks noGrp="1" noRot="1" noChangeAspect="1"/>
+          </p:cNvSpPr>
+          <p:nvPr>
+            <p:ph type="sldImg"/>
+          </p:nvPr>
+        </p:nvSpPr>
+        <p:spPr/>
+      </p:sp>
+      <p:sp>
+        <p:nvSpPr>
+          <p:cNvPr id="3" name="Notes Placeholder 2"/>
+          <p:cNvSpPr>
+            <a:spLocks noGrp="1"/>
+          </p:cNvSpPr>
+          <p:nvPr>
+            <p:ph type="body" idx="1"/>
+          </p:nvPr>
+        </p:nvSpPr>
+        <p:spPr/>
+        <p:txBody>
+          <a:bodyPr/>
+          <a:lstStyle/>
+          <a:p>
+            <a:r>
+              <a:rPr lang="en-US" dirty="0"/>
+              <a:t/>
+            </a:r>
+            <a:endParaRPr lang="en-US" dirty="0"/>
+          </a:p>
+        </p:txBody>
+      </p:sp>
+      <p:sp>
+        <p:nvSpPr>
+          <p:cNvPr id="4" name="Slide Number Placeholder 3"/>
+          <p:cNvSpPr>
+            <a:spLocks noGrp="1"/>
+          </p:cNvSpPr>
+          <p:nvPr>
+            <p:ph type="sldNum" sz="quarter" idx="10"/>
+          </p:nvPr>
+        </p:nvSpPr>
+        <p:spPr/>
+        <p:txBody>
+          <a:bodyPr/>
+          <a:lstStyle/>
+          <a:p>
+            <a:fld id="{F7021451-1387-4CA6-816F-3879F97B5CBC}" type="slidenum">
+              <a:rPr lang="en-US"/>
+              <a:t>23</a:t>
+            </a:fld>
+            <a:endParaRPr lang="en-US"/>
+          </a:p>
+        </p:txBody>
+      </p:sp>
+    </p:spTree>
+    <p:extLst>
+      <p:ext uri="{BB962C8B-B14F-4D97-AF65-F5344CB8AC3E}">
+        <p14:creationId xmlns:p14="http://schemas.microsoft.com/office/powerpoint/2010/main" val="1024086991"/>
+      </p:ext>
+    </p:extLst>
+  </p:cSld>
+  <p:clrMapOvr>
+    <a:masterClrMapping/>
+  </p:clrMapOvr>
+</p:notes>
+</file>
+
+<file path=ppt/notesSlides/notesSlide24.xml><?xml version="1.0" encoding="utf-8"?>
+<p:notes xmlns:a="http://schemas.openxmlformats.org/drawingml/2006/main" xmlns:r="http://schemas.openxmlformats.org/officeDocument/2006/relationships" xmlns:p="http://schemas.openxmlformats.org/presentationml/2006/main">
+  <p:cSld>
+    <p:spTree>
+      <p:nvGrpSpPr>
+        <p:cNvPr id="1" name=""/>
+        <p:cNvGrpSpPr/>
+        <p:nvPr/>
+      </p:nvGrpSpPr>
+      <p:grpSpPr>
+        <a:xfrm>
+          <a:off x="0" y="0"/>
+          <a:ext cx="0" cy="0"/>
+          <a:chOff x="0" y="0"/>
+          <a:chExt cx="0" cy="0"/>
+        </a:xfrm>
+      </p:grpSpPr>
+      <p:sp>
+        <p:nvSpPr>
+          <p:cNvPr id="2" name="Slide Image Placeholder 1"/>
+          <p:cNvSpPr>
+            <a:spLocks noGrp="1" noRot="1" noChangeAspect="1"/>
+          </p:cNvSpPr>
+          <p:nvPr>
+            <p:ph type="sldImg"/>
+          </p:nvPr>
+        </p:nvSpPr>
+        <p:spPr/>
+      </p:sp>
+      <p:sp>
+        <p:nvSpPr>
+          <p:cNvPr id="3" name="Notes Placeholder 2"/>
+          <p:cNvSpPr>
+            <a:spLocks noGrp="1"/>
+          </p:cNvSpPr>
+          <p:nvPr>
+            <p:ph type="body" idx="1"/>
+          </p:nvPr>
+        </p:nvSpPr>
+        <p:spPr/>
+        <p:txBody>
+          <a:bodyPr/>
+          <a:lstStyle/>
+          <a:p>
+            <a:r>
+              <a:rPr lang="en-US" dirty="0"/>
+              <a:t/>
+            </a:r>
+            <a:endParaRPr lang="en-US" dirty="0"/>
+          </a:p>
+        </p:txBody>
+      </p:sp>
+      <p:sp>
+        <p:nvSpPr>
+          <p:cNvPr id="4" name="Slide Number Placeholder 3"/>
+          <p:cNvSpPr>
+            <a:spLocks noGrp="1"/>
+          </p:cNvSpPr>
+          <p:nvPr>
+            <p:ph type="sldNum" sz="quarter" idx="10"/>
+          </p:nvPr>
+        </p:nvSpPr>
+        <p:spPr/>
+        <p:txBody>
+          <a:bodyPr/>
+          <a:lstStyle/>
+          <a:p>
+            <a:fld id="{F7021451-1387-4CA6-816F-3879F97B5CBC}" type="slidenum">
+              <a:rPr lang="en-US"/>
+              <a:t>24</a:t>
+            </a:fld>
+            <a:endParaRPr lang="en-US"/>
+          </a:p>
+        </p:txBody>
+      </p:sp>
+    </p:spTree>
+    <p:extLst>
+      <p:ext uri="{BB962C8B-B14F-4D97-AF65-F5344CB8AC3E}">
+        <p14:creationId xmlns:p14="http://schemas.microsoft.com/office/powerpoint/2010/main" val="1024086991"/>
+      </p:ext>
+    </p:extLst>
+  </p:cSld>
+  <p:clrMapOvr>
+    <a:masterClrMapping/>
+  </p:clrMapOvr>
+</p:notes>
+</file>
+
+<file path=ppt/notesSlides/notesSlide25.xml><?xml version="1.0" encoding="utf-8"?>
+<p:notes xmlns:a="http://schemas.openxmlformats.org/drawingml/2006/main" xmlns:r="http://schemas.openxmlformats.org/officeDocument/2006/relationships" xmlns:p="http://schemas.openxmlformats.org/presentationml/2006/main">
+  <p:cSld>
+    <p:spTree>
+      <p:nvGrpSpPr>
+        <p:cNvPr id="1" name=""/>
+        <p:cNvGrpSpPr/>
+        <p:nvPr/>
+      </p:nvGrpSpPr>
+      <p:grpSpPr>
+        <a:xfrm>
+          <a:off x="0" y="0"/>
+          <a:ext cx="0" cy="0"/>
+          <a:chOff x="0" y="0"/>
+          <a:chExt cx="0" cy="0"/>
+        </a:xfrm>
+      </p:grpSpPr>
+      <p:sp>
+        <p:nvSpPr>
+          <p:cNvPr id="2" name="Slide Image Placeholder 1"/>
+          <p:cNvSpPr>
+            <a:spLocks noGrp="1" noRot="1" noChangeAspect="1"/>
+          </p:cNvSpPr>
+          <p:nvPr>
+            <p:ph type="sldImg"/>
+          </p:nvPr>
+        </p:nvSpPr>
+        <p:spPr/>
+      </p:sp>
+      <p:sp>
+        <p:nvSpPr>
+          <p:cNvPr id="3" name="Notes Placeholder 2"/>
+          <p:cNvSpPr>
+            <a:spLocks noGrp="1"/>
+          </p:cNvSpPr>
+          <p:nvPr>
+            <p:ph type="body" idx="1"/>
+          </p:nvPr>
+        </p:nvSpPr>
+        <p:spPr/>
+        <p:txBody>
+          <a:bodyPr/>
+          <a:lstStyle/>
+          <a:p>
+            <a:r>
+              <a:rPr lang="en-US" dirty="0"/>
+              <a:t/>
+            </a:r>
+            <a:endParaRPr lang="en-US" dirty="0"/>
+          </a:p>
+        </p:txBody>
+      </p:sp>
+      <p:sp>
+        <p:nvSpPr>
+          <p:cNvPr id="4" name="Slide Number Placeholder 3"/>
+          <p:cNvSpPr>
+            <a:spLocks noGrp="1"/>
+          </p:cNvSpPr>
+          <p:nvPr>
+            <p:ph type="sldNum" sz="quarter" idx="10"/>
+          </p:nvPr>
+        </p:nvSpPr>
+        <p:spPr/>
+        <p:txBody>
+          <a:bodyPr/>
+          <a:lstStyle/>
+          <a:p>
+            <a:fld id="{F7021451-1387-4CA6-816F-3879F97B5CBC}" type="slidenum">
+              <a:rPr lang="en-US"/>
+              <a:t>25</a:t>
+            </a:fld>
+            <a:endParaRPr lang="en-US"/>
+          </a:p>
+        </p:txBody>
+      </p:sp>
+    </p:spTree>
+    <p:extLst>
+      <p:ext uri="{BB962C8B-B14F-4D97-AF65-F5344CB8AC3E}">
+        <p14:creationId xmlns:p14="http://schemas.microsoft.com/office/powerpoint/2010/main" val="1024086991"/>
+      </p:ext>
+    </p:extLst>
+  </p:cSld>
+  <p:clrMapOvr>
+    <a:masterClrMapping/>
+  </p:clrMapOvr>
+</p:notes>
+</file>
+
+<file path=ppt/notesSlides/notesSlide26.xml><?xml version="1.0" encoding="utf-8"?>
+<p:notes xmlns:a="http://schemas.openxmlformats.org/drawingml/2006/main" xmlns:r="http://schemas.openxmlformats.org/officeDocument/2006/relationships" xmlns:p="http://schemas.openxmlformats.org/presentationml/2006/main">
+  <p:cSld>
+    <p:spTree>
+      <p:nvGrpSpPr>
+        <p:cNvPr id="1" name=""/>
+        <p:cNvGrpSpPr/>
+        <p:nvPr/>
+      </p:nvGrpSpPr>
+      <p:grpSpPr>
+        <a:xfrm>
+          <a:off x="0" y="0"/>
+          <a:ext cx="0" cy="0"/>
+          <a:chOff x="0" y="0"/>
+          <a:chExt cx="0" cy="0"/>
+        </a:xfrm>
+      </p:grpSpPr>
+      <p:sp>
+        <p:nvSpPr>
+          <p:cNvPr id="2" name="Slide Image Placeholder 1"/>
+          <p:cNvSpPr>
+            <a:spLocks noGrp="1" noRot="1" noChangeAspect="1"/>
+          </p:cNvSpPr>
+          <p:nvPr>
+            <p:ph type="sldImg"/>
+          </p:nvPr>
+        </p:nvSpPr>
+        <p:spPr/>
+      </p:sp>
+      <p:sp>
+        <p:nvSpPr>
+          <p:cNvPr id="3" name="Notes Placeholder 2"/>
+          <p:cNvSpPr>
+            <a:spLocks noGrp="1"/>
+          </p:cNvSpPr>
+          <p:nvPr>
+            <p:ph type="body" idx="1"/>
+          </p:nvPr>
+        </p:nvSpPr>
+        <p:spPr/>
+        <p:txBody>
+          <a:bodyPr/>
+          <a:lstStyle/>
+          <a:p>
+            <a:r>
+              <a:rPr lang="en-US" dirty="0"/>
+              <a:t/>
+            </a:r>
+            <a:endParaRPr lang="en-US" dirty="0"/>
+          </a:p>
+        </p:txBody>
+      </p:sp>
+      <p:sp>
+        <p:nvSpPr>
+          <p:cNvPr id="4" name="Slide Number Placeholder 3"/>
+          <p:cNvSpPr>
+            <a:spLocks noGrp="1"/>
+          </p:cNvSpPr>
+          <p:nvPr>
+            <p:ph type="sldNum" sz="quarter" idx="10"/>
+          </p:nvPr>
+        </p:nvSpPr>
+        <p:spPr/>
+        <p:txBody>
+          <a:bodyPr/>
+          <a:lstStyle/>
+          <a:p>
+            <a:fld id="{F7021451-1387-4CA6-816F-3879F97B5CBC}" type="slidenum">
+              <a:rPr lang="en-US"/>
+              <a:t>26</a:t>
             </a:fld>
             <a:endParaRPr lang="en-US"/>
           </a:p>
@@ -3141,6 +3586,201 @@
 <file path=ppt/slides/slide21.xml><?xml version="1.0" encoding="utf-8"?>
 <p:sld xmlns:a="http://schemas.openxmlformats.org/drawingml/2006/main" xmlns:r="http://schemas.openxmlformats.org/officeDocument/2006/relationships" xmlns:p="http://schemas.openxmlformats.org/presentationml/2006/main">
   <p:cSld name="Slide 21">
+    <p:bg>
+      <p:bgPr>
+        <a:blipFill dpi="0" rotWithShape="1">
+          <a:blip r:embed="rId1">
+            <a:lum/>
+          </a:blip>
+          <a:srcRect/>
+          <a:stretch>
+            <a:fillRect/>
+          </a:stretch>
+        </a:blipFill>
+        <a:effectLst/>
+      </p:bgPr>
+    </p:bg>
+    <p:spTree>
+      <p:nvGrpSpPr>
+        <p:cNvPr id="1" name=""/>
+        <p:cNvGrpSpPr/>
+        <p:nvPr/>
+      </p:nvGrpSpPr>
+      <p:grpSpPr>
+        <a:xfrm>
+          <a:off x="0" y="0"/>
+          <a:ext cx="0" cy="0"/>
+          <a:chOff x="0" y="0"/>
+          <a:chExt cx="0" cy="0"/>
+        </a:xfrm>
+      </p:grpSpPr>
+    </p:spTree>
+  </p:cSld>
+  <p:clrMapOvr>
+    <a:masterClrMapping/>
+  </p:clrMapOvr>
+</p:sld>
+</file>
+
+<file path=ppt/slides/slide22.xml><?xml version="1.0" encoding="utf-8"?>
+<p:sld xmlns:a="http://schemas.openxmlformats.org/drawingml/2006/main" xmlns:r="http://schemas.openxmlformats.org/officeDocument/2006/relationships" xmlns:p="http://schemas.openxmlformats.org/presentationml/2006/main">
+  <p:cSld name="Slide 22">
+    <p:bg>
+      <p:bgPr>
+        <a:blipFill dpi="0" rotWithShape="1">
+          <a:blip r:embed="rId1">
+            <a:lum/>
+          </a:blip>
+          <a:srcRect/>
+          <a:stretch>
+            <a:fillRect/>
+          </a:stretch>
+        </a:blipFill>
+        <a:effectLst/>
+      </p:bgPr>
+    </p:bg>
+    <p:spTree>
+      <p:nvGrpSpPr>
+        <p:cNvPr id="1" name=""/>
+        <p:cNvGrpSpPr/>
+        <p:nvPr/>
+      </p:nvGrpSpPr>
+      <p:grpSpPr>
+        <a:xfrm>
+          <a:off x="0" y="0"/>
+          <a:ext cx="0" cy="0"/>
+          <a:chOff x="0" y="0"/>
+          <a:chExt cx="0" cy="0"/>
+        </a:xfrm>
+      </p:grpSpPr>
+    </p:spTree>
+  </p:cSld>
+  <p:clrMapOvr>
+    <a:masterClrMapping/>
+  </p:clrMapOvr>
+</p:sld>
+</file>
+
+<file path=ppt/slides/slide23.xml><?xml version="1.0" encoding="utf-8"?>
+<p:sld xmlns:a="http://schemas.openxmlformats.org/drawingml/2006/main" xmlns:r="http://schemas.openxmlformats.org/officeDocument/2006/relationships" xmlns:p="http://schemas.openxmlformats.org/presentationml/2006/main">
+  <p:cSld name="Slide 23">
+    <p:bg>
+      <p:bgPr>
+        <a:blipFill dpi="0" rotWithShape="1">
+          <a:blip r:embed="rId1">
+            <a:lum/>
+          </a:blip>
+          <a:srcRect/>
+          <a:stretch>
+            <a:fillRect/>
+          </a:stretch>
+        </a:blipFill>
+        <a:effectLst/>
+      </p:bgPr>
+    </p:bg>
+    <p:spTree>
+      <p:nvGrpSpPr>
+        <p:cNvPr id="1" name=""/>
+        <p:cNvGrpSpPr/>
+        <p:nvPr/>
+      </p:nvGrpSpPr>
+      <p:grpSpPr>
+        <a:xfrm>
+          <a:off x="0" y="0"/>
+          <a:ext cx="0" cy="0"/>
+          <a:chOff x="0" y="0"/>
+          <a:chExt cx="0" cy="0"/>
+        </a:xfrm>
+      </p:grpSpPr>
+    </p:spTree>
+  </p:cSld>
+  <p:clrMapOvr>
+    <a:masterClrMapping/>
+  </p:clrMapOvr>
+</p:sld>
+</file>
+
+<file path=ppt/slides/slide24.xml><?xml version="1.0" encoding="utf-8"?>
+<p:sld xmlns:a="http://schemas.openxmlformats.org/drawingml/2006/main" xmlns:r="http://schemas.openxmlformats.org/officeDocument/2006/relationships" xmlns:p="http://schemas.openxmlformats.org/presentationml/2006/main">
+  <p:cSld name="Slide 24">
+    <p:bg>
+      <p:bgPr>
+        <a:blipFill dpi="0" rotWithShape="1">
+          <a:blip r:embed="rId1">
+            <a:lum/>
+          </a:blip>
+          <a:srcRect/>
+          <a:stretch>
+            <a:fillRect/>
+          </a:stretch>
+        </a:blipFill>
+        <a:effectLst/>
+      </p:bgPr>
+    </p:bg>
+    <p:spTree>
+      <p:nvGrpSpPr>
+        <p:cNvPr id="1" name=""/>
+        <p:cNvGrpSpPr/>
+        <p:nvPr/>
+      </p:nvGrpSpPr>
+      <p:grpSpPr>
+        <a:xfrm>
+          <a:off x="0" y="0"/>
+          <a:ext cx="0" cy="0"/>
+          <a:chOff x="0" y="0"/>
+          <a:chExt cx="0" cy="0"/>
+        </a:xfrm>
+      </p:grpSpPr>
+    </p:spTree>
+  </p:cSld>
+  <p:clrMapOvr>
+    <a:masterClrMapping/>
+  </p:clrMapOvr>
+</p:sld>
+</file>
+
+<file path=ppt/slides/slide25.xml><?xml version="1.0" encoding="utf-8"?>
+<p:sld xmlns:a="http://schemas.openxmlformats.org/drawingml/2006/main" xmlns:r="http://schemas.openxmlformats.org/officeDocument/2006/relationships" xmlns:p="http://schemas.openxmlformats.org/presentationml/2006/main">
+  <p:cSld name="Slide 25">
+    <p:bg>
+      <p:bgPr>
+        <a:blipFill dpi="0" rotWithShape="1">
+          <a:blip r:embed="rId1">
+            <a:lum/>
+          </a:blip>
+          <a:srcRect/>
+          <a:stretch>
+            <a:fillRect/>
+          </a:stretch>
+        </a:blipFill>
+        <a:effectLst/>
+      </p:bgPr>
+    </p:bg>
+    <p:spTree>
+      <p:nvGrpSpPr>
+        <p:cNvPr id="1" name=""/>
+        <p:cNvGrpSpPr/>
+        <p:nvPr/>
+      </p:nvGrpSpPr>
+      <p:grpSpPr>
+        <a:xfrm>
+          <a:off x="0" y="0"/>
+          <a:ext cx="0" cy="0"/>
+          <a:chOff x="0" y="0"/>
+          <a:chExt cx="0" cy="0"/>
+        </a:xfrm>
+      </p:grpSpPr>
+    </p:spTree>
+  </p:cSld>
+  <p:clrMapOvr>
+    <a:masterClrMapping/>
+  </p:clrMapOvr>
+</p:sld>
+</file>
+
+<file path=ppt/slides/slide26.xml><?xml version="1.0" encoding="utf-8"?>
+<p:sld xmlns:a="http://schemas.openxmlformats.org/drawingml/2006/main" xmlns:r="http://schemas.openxmlformats.org/officeDocument/2006/relationships" xmlns:p="http://schemas.openxmlformats.org/presentationml/2006/main">
+  <p:cSld name="Slide 26">
     <p:bg>
       <p:bgPr>
         <a:blipFill dpi="0" rotWithShape="1">

</xml_diff>

<commit_message>
feat(presentation): add team slide with avatar, rebuild PDF/PPTX
</commit_message>
<xml_diff>
--- a/presentation/slides.pptx
+++ b/presentation/slides.pptx
@@ -31,9 +31,10 @@
     <p:sldId id="279" r:id="rId25"/>
     <p:sldId id="280" r:id="rId26"/>
     <p:sldId id="281" r:id="rId27"/>
+    <p:sldId id="282" r:id="rId28"/>
   </p:sldIdLst>
   <p:notesMasterIdLst>
-    <p:notesMasterId r:id="rId28"/>
+    <p:notesMasterId r:id="rId29"/>
   </p:notesMasterIdLst>
   <p:sldSz cx="9334500" cy="5248275"/>
   <p:notesSz cx="5248275" cy="9334500"/>
@@ -2135,6 +2136,94 @@
             <a:fld id="{F7021451-1387-4CA6-816F-3879F97B5CBC}" type="slidenum">
               <a:rPr lang="en-US"/>
               <a:t>26</a:t>
+            </a:fld>
+            <a:endParaRPr lang="en-US"/>
+          </a:p>
+        </p:txBody>
+      </p:sp>
+    </p:spTree>
+    <p:extLst>
+      <p:ext uri="{BB962C8B-B14F-4D97-AF65-F5344CB8AC3E}">
+        <p14:creationId xmlns:p14="http://schemas.microsoft.com/office/powerpoint/2010/main" val="1024086991"/>
+      </p:ext>
+    </p:extLst>
+  </p:cSld>
+  <p:clrMapOvr>
+    <a:masterClrMapping/>
+  </p:clrMapOvr>
+</p:notes>
+</file>
+
+<file path=ppt/notesSlides/notesSlide27.xml><?xml version="1.0" encoding="utf-8"?>
+<p:notes xmlns:a="http://schemas.openxmlformats.org/drawingml/2006/main" xmlns:r="http://schemas.openxmlformats.org/officeDocument/2006/relationships" xmlns:p="http://schemas.openxmlformats.org/presentationml/2006/main">
+  <p:cSld>
+    <p:spTree>
+      <p:nvGrpSpPr>
+        <p:cNvPr id="1" name=""/>
+        <p:cNvGrpSpPr/>
+        <p:nvPr/>
+      </p:nvGrpSpPr>
+      <p:grpSpPr>
+        <a:xfrm>
+          <a:off x="0" y="0"/>
+          <a:ext cx="0" cy="0"/>
+          <a:chOff x="0" y="0"/>
+          <a:chExt cx="0" cy="0"/>
+        </a:xfrm>
+      </p:grpSpPr>
+      <p:sp>
+        <p:nvSpPr>
+          <p:cNvPr id="2" name="Slide Image Placeholder 1"/>
+          <p:cNvSpPr>
+            <a:spLocks noGrp="1" noRot="1" noChangeAspect="1"/>
+          </p:cNvSpPr>
+          <p:nvPr>
+            <p:ph type="sldImg"/>
+          </p:nvPr>
+        </p:nvSpPr>
+        <p:spPr/>
+      </p:sp>
+      <p:sp>
+        <p:nvSpPr>
+          <p:cNvPr id="3" name="Notes Placeholder 2"/>
+          <p:cNvSpPr>
+            <a:spLocks noGrp="1"/>
+          </p:cNvSpPr>
+          <p:nvPr>
+            <p:ph type="body" idx="1"/>
+          </p:nvPr>
+        </p:nvSpPr>
+        <p:spPr/>
+        <p:txBody>
+          <a:bodyPr/>
+          <a:lstStyle/>
+          <a:p>
+            <a:r>
+              <a:rPr lang="en-US" dirty="0"/>
+              <a:t/>
+            </a:r>
+            <a:endParaRPr lang="en-US" dirty="0"/>
+          </a:p>
+        </p:txBody>
+      </p:sp>
+      <p:sp>
+        <p:nvSpPr>
+          <p:cNvPr id="4" name="Slide Number Placeholder 3"/>
+          <p:cNvSpPr>
+            <a:spLocks noGrp="1"/>
+          </p:cNvSpPr>
+          <p:nvPr>
+            <p:ph type="sldNum" sz="quarter" idx="10"/>
+          </p:nvPr>
+        </p:nvSpPr>
+        <p:spPr/>
+        <p:txBody>
+          <a:bodyPr/>
+          <a:lstStyle/>
+          <a:p>
+            <a:fld id="{F7021451-1387-4CA6-816F-3879F97B5CBC}" type="slidenum">
+              <a:rPr lang="en-US"/>
+              <a:t>27</a:t>
             </a:fld>
             <a:endParaRPr lang="en-US"/>
           </a:p>
@@ -3781,6 +3870,45 @@
 <file path=ppt/slides/slide26.xml><?xml version="1.0" encoding="utf-8"?>
 <p:sld xmlns:a="http://schemas.openxmlformats.org/drawingml/2006/main" xmlns:r="http://schemas.openxmlformats.org/officeDocument/2006/relationships" xmlns:p="http://schemas.openxmlformats.org/presentationml/2006/main">
   <p:cSld name="Slide 26">
+    <p:bg>
+      <p:bgPr>
+        <a:blipFill dpi="0" rotWithShape="1">
+          <a:blip r:embed="rId1">
+            <a:lum/>
+          </a:blip>
+          <a:srcRect/>
+          <a:stretch>
+            <a:fillRect/>
+          </a:stretch>
+        </a:blipFill>
+        <a:effectLst/>
+      </p:bgPr>
+    </p:bg>
+    <p:spTree>
+      <p:nvGrpSpPr>
+        <p:cNvPr id="1" name=""/>
+        <p:cNvGrpSpPr/>
+        <p:nvPr/>
+      </p:nvGrpSpPr>
+      <p:grpSpPr>
+        <a:xfrm>
+          <a:off x="0" y="0"/>
+          <a:ext cx="0" cy="0"/>
+          <a:chOff x="0" y="0"/>
+          <a:chExt cx="0" cy="0"/>
+        </a:xfrm>
+      </p:grpSpPr>
+    </p:spTree>
+  </p:cSld>
+  <p:clrMapOvr>
+    <a:masterClrMapping/>
+  </p:clrMapOvr>
+</p:sld>
+</file>
+
+<file path=ppt/slides/slide27.xml><?xml version="1.0" encoding="utf-8"?>
+<p:sld xmlns:a="http://schemas.openxmlformats.org/drawingml/2006/main" xmlns:r="http://schemas.openxmlformats.org/officeDocument/2006/relationships" xmlns:p="http://schemas.openxmlformats.org/presentationml/2006/main">
+  <p:cSld name="Slide 27">
     <p:bg>
       <p:bgPr>
         <a:blipFill dpi="0" rotWithShape="1">

</xml_diff>

<commit_message>
feat(presentation): polish the deck, add the light theme and charts (#21)
- contrast: --text #EDEDED, --secondary #B8B8B8, --caption #A6A6A6, and
  --highlight #A2391D -> #D0603A; every text colour now clears WCAG AA
  (captions and the accent were the weak points)
- slide 5: drop the duplicated architecture subtitle and crop the figure so
  it renders larger
- slide 13: colour the bars good/bad, label them matched/mismatched, add the
  max-1.00 guide and the +80-counterexamples annotation; align the wording
  with matched/mismatched
- slide 17: 60/40 grid, larger web screenshot, the three points build on click
- slide 22: three KPI figures and two labelled QR codes (repo + release)
- light theme: slides-light.md generated from slides.md by build_light.py,
  light chart variants built from the same code, light tokens in style.css
- rebuild slides.pdf, slides-light.pdf, slides.pptx and presentation_html.zip;
  both PDFs are 22 pages with no blank pages and no overflow
</commit_message>
<xml_diff>
--- a/presentation/slides.pptx
+++ b/presentation/slides.pptx
@@ -943,7 +943,7 @@
           <a:lstStyle/>
           <a:p>
             <a:r>
-              <a:t>QR ведёт на репозиторий; отчёт REPORT.md.</a:t>
+              <a:t>QR ведёт на репозиторий и на релиз v1.0.0; отчёт REPORT.md.</a:t>
             </a:r>
           </a:p>
         </p:txBody>
@@ -4007,7 +4007,7 @@
             <a:avLst/>
           </a:prstGeom>
           <a:solidFill>
-            <a:srgbClr val="A2391D"/>
+            <a:srgbClr val="D0603A"/>
           </a:solidFill>
           <a:ln>
             <a:noFill/>
@@ -4094,7 +4094,7 @@
             <a:r>
               <a:rPr sz="2000" b="0">
                 <a:solidFill>
-                  <a:srgbClr val="B0B0B0"/>
+                  <a:srgbClr val="B8B8B8"/>
                 </a:solidFill>
                 <a:latin typeface="Inter"/>
               </a:rPr>
@@ -4128,7 +4128,7 @@
             <a:r>
               <a:rPr sz="1500" b="0">
                 <a:solidFill>
-                  <a:srgbClr val="B0B0B0"/>
+                  <a:srgbClr val="B8B8B8"/>
                 </a:solidFill>
                 <a:latin typeface="Inter"/>
               </a:rPr>
@@ -4188,7 +4188,7 @@
             <a:r>
               <a:rPr sz="1000">
                 <a:solidFill>
-                  <a:srgbClr val="9A9A9A"/>
+                  <a:srgbClr val="A6A6A6"/>
                 </a:solidFill>
                 <a:latin typeface="Inter"/>
               </a:rPr>
@@ -4268,6 +4268,7 @@
       </p:par>
     </p:tnLst>
   </p:timing>
+  <p:transition spd="med" fade="1"/>
 </p:sld>
 </file>
 
@@ -4339,7 +4340,7 @@
             <a:avLst/>
           </a:prstGeom>
           <a:solidFill>
-            <a:srgbClr val="A2391D"/>
+            <a:srgbClr val="D0603A"/>
           </a:solidFill>
           <a:ln>
             <a:noFill/>
@@ -4459,7 +4460,7 @@
             <a:avLst/>
           </a:prstGeom>
           <a:solidFill>
-            <a:srgbClr val="A2391D"/>
+            <a:srgbClr val="D0603A"/>
           </a:solidFill>
           <a:ln>
             <a:noFill/>
@@ -4523,7 +4524,7 @@
             <a:r>
               <a:rPr sz="1500" b="0">
                 <a:solidFill>
-                  <a:srgbClr val="F0F0F0"/>
+                  <a:srgbClr val="EDEDED"/>
                 </a:solidFill>
                 <a:latin typeface="Inter"/>
               </a:rPr>
@@ -4590,7 +4591,7 @@
             <a:avLst/>
           </a:prstGeom>
           <a:solidFill>
-            <a:srgbClr val="A2391D"/>
+            <a:srgbClr val="D0603A"/>
           </a:solidFill>
           <a:ln>
             <a:noFill/>
@@ -4654,7 +4655,7 @@
             <a:r>
               <a:rPr sz="1500" b="0">
                 <a:solidFill>
-                  <a:srgbClr val="F0F0F0"/>
+                  <a:srgbClr val="EDEDED"/>
                 </a:solidFill>
                 <a:latin typeface="Inter"/>
               </a:rPr>
@@ -4721,7 +4722,7 @@
             <a:avLst/>
           </a:prstGeom>
           <a:solidFill>
-            <a:srgbClr val="A2391D"/>
+            <a:srgbClr val="D0603A"/>
           </a:solidFill>
           <a:ln>
             <a:noFill/>
@@ -4785,7 +4786,7 @@
             <a:r>
               <a:rPr sz="1500" b="0">
                 <a:solidFill>
-                  <a:srgbClr val="F0F0F0"/>
+                  <a:srgbClr val="EDEDED"/>
                 </a:solidFill>
                 <a:latin typeface="Inter"/>
               </a:rPr>
@@ -4819,7 +4820,7 @@
             <a:r>
               <a:rPr sz="1100" b="0">
                 <a:solidFill>
-                  <a:srgbClr val="9A9A9A"/>
+                  <a:srgbClr val="A6A6A6"/>
                 </a:solidFill>
                 <a:latin typeface="Inter"/>
               </a:rPr>
@@ -4854,7 +4855,7 @@
             <a:r>
               <a:rPr sz="1000">
                 <a:solidFill>
-                  <a:srgbClr val="9A9A9A"/>
+                  <a:srgbClr val="A6A6A6"/>
                 </a:solidFill>
                 <a:latin typeface="Inter"/>
               </a:rPr>
@@ -5034,6 +5035,7 @@
       </p:par>
     </p:tnLst>
   </p:timing>
+  <p:transition spd="med" fade="1"/>
 </p:sld>
 </file>
 
@@ -5105,7 +5107,7 @@
             <a:avLst/>
           </a:prstGeom>
           <a:solidFill>
-            <a:srgbClr val="A2391D"/>
+            <a:srgbClr val="D0603A"/>
           </a:solidFill>
           <a:ln>
             <a:noFill/>
@@ -5216,7 +5218,7 @@
             <a:avLst/>
           </a:prstGeom>
           <a:solidFill>
-            <a:srgbClr val="A2391D"/>
+            <a:srgbClr val="D0603A"/>
           </a:solidFill>
           <a:ln>
             <a:noFill/>
@@ -5270,7 +5272,7 @@
             <a:r>
               <a:rPr sz="1000">
                 <a:solidFill>
-                  <a:srgbClr val="9A9A9A"/>
+                  <a:srgbClr val="A6A6A6"/>
                 </a:solidFill>
                 <a:latin typeface="Inter"/>
               </a:rPr>
@@ -5422,7 +5424,7 @@
             <a:avLst/>
           </a:prstGeom>
           <a:solidFill>
-            <a:srgbClr val="A2391D"/>
+            <a:srgbClr val="D0603A"/>
           </a:solidFill>
           <a:ln>
             <a:noFill/>
@@ -5501,7 +5503,7 @@
         <p:spPr>
           <a:xfrm>
             <a:off x="571500" y="1554480"/>
-            <a:ext cx="10873945" cy="4023359"/>
+            <a:ext cx="10894978" cy="4023360"/>
           </a:xfrm>
           <a:prstGeom prst="rect">
             <a:avLst/>
@@ -5533,7 +5535,7 @@
             <a:r>
               <a:rPr sz="1100" b="0">
                 <a:solidFill>
-                  <a:srgbClr val="9A9A9A"/>
+                  <a:srgbClr val="A6A6A6"/>
                 </a:solidFill>
                 <a:latin typeface="Inter"/>
               </a:rPr>
@@ -5568,7 +5570,7 @@
             <a:r>
               <a:rPr sz="1000">
                 <a:solidFill>
-                  <a:srgbClr val="9A9A9A"/>
+                  <a:srgbClr val="A6A6A6"/>
                 </a:solidFill>
                 <a:latin typeface="Inter"/>
               </a:rPr>
@@ -5582,6 +5584,7 @@
   <p:clrMapOvr>
     <a:masterClrMapping/>
   </p:clrMapOvr>
+  <p:transition spd="med" fade="1"/>
 </p:sld>
 </file>
 
@@ -5653,7 +5656,7 @@
             <a:avLst/>
           </a:prstGeom>
           <a:solidFill>
-            <a:srgbClr val="A2391D"/>
+            <a:srgbClr val="D0603A"/>
           </a:solidFill>
           <a:ln>
             <a:noFill/>
@@ -5745,11 +5748,11 @@
             <a:r>
               <a:rPr sz="1700" b="0">
                 <a:solidFill>
-                  <a:srgbClr val="F0F0F0"/>
+                  <a:srgbClr val="EDEDED"/>
                 </a:solidFill>
                 <a:latin typeface="Inter"/>
               </a:rPr>
-              <a:t>•  Чтение, объявленное правилом v1, даёт 0.43 (60 support, 80 contradict).</a:t>
+              <a:t>•  Чтение, объявленное правилом v1, даёт 0.43 (60 matched, 80 mismatched).</a:t>
             </a:r>
           </a:p>
           <a:p>
@@ -5761,11 +5764,11 @@
             <a:r>
               <a:rPr sz="1700" b="0">
                 <a:solidFill>
-                  <a:srgbClr val="F0F0F0"/>
+                  <a:srgbClr val="EDEDED"/>
                 </a:solidFill>
                 <a:latin typeface="Inter"/>
               </a:rPr>
-              <a:t>•  После уточнения v2: 140 matched, 0 контрпримеров.</a:t>
+              <a:t>•  Каждый mismatched-байт привязан к пакету-источнику и сохранён.</a:t>
             </a:r>
           </a:p>
           <a:p>
@@ -5777,7 +5780,23 @@
             <a:r>
               <a:rPr sz="1700" b="0">
                 <a:solidFill>
-                  <a:srgbClr val="F0F0F0"/>
+                  <a:srgbClr val="EDEDED"/>
+                </a:solidFill>
+                <a:latin typeface="Inter"/>
+              </a:rPr>
+              <a:t>•  После уточнения v2: 140 matched, 0 контрпримеров.</a:t>
+            </a:r>
+          </a:p>
+          <a:p>
+            <a:pPr>
+              <a:spcAft>
+                <a:spcPts val="1000"/>
+              </a:spcAft>
+            </a:pPr>
+            <a:r>
+              <a:rPr sz="1700" b="0">
+                <a:solidFill>
+                  <a:srgbClr val="EDEDED"/>
                 </a:solidFill>
                 <a:latin typeface="Inter"/>
               </a:rPr>
@@ -5803,7 +5822,7 @@
         <p:spPr>
           <a:xfrm>
             <a:off x="6240780" y="1554480"/>
-            <a:ext cx="5379415" cy="3533603"/>
+            <a:ext cx="5379415" cy="3531201"/>
           </a:xfrm>
           <a:prstGeom prst="rect">
             <a:avLst/>
@@ -5835,7 +5854,7 @@
             <a:r>
               <a:rPr sz="1100" b="0">
                 <a:solidFill>
-                  <a:srgbClr val="9A9A9A"/>
+                  <a:srgbClr val="A6A6A6"/>
                 </a:solidFill>
                 <a:latin typeface="Inter"/>
               </a:rPr>
@@ -5870,7 +5889,7 @@
             <a:r>
               <a:rPr sz="1000">
                 <a:solidFill>
-                  <a:srgbClr val="9A9A9A"/>
+                  <a:srgbClr val="A6A6A6"/>
                 </a:solidFill>
                 <a:latin typeface="Inter"/>
               </a:rPr>
@@ -5884,6 +5903,7 @@
   <p:clrMapOvr>
     <a:masterClrMapping/>
   </p:clrMapOvr>
+  <p:transition spd="med" fade="1"/>
 </p:sld>
 </file>
 
@@ -5955,7 +5975,7 @@
             <a:avLst/>
           </a:prstGeom>
           <a:solidFill>
-            <a:srgbClr val="A2391D"/>
+            <a:srgbClr val="D0603A"/>
           </a:solidFill>
           <a:ln>
             <a:noFill/>
@@ -6047,7 +6067,7 @@
             <a:r>
               <a:rPr sz="1700" b="0">
                 <a:solidFill>
-                  <a:srgbClr val="F0F0F0"/>
+                  <a:srgbClr val="EDEDED"/>
                 </a:solidFill>
                 <a:latin typeface="Inter"/>
               </a:rPr>
@@ -6063,7 +6083,7 @@
             <a:r>
               <a:rPr sz="1700" b="0">
                 <a:solidFill>
-                  <a:srgbClr val="F0F0F0"/>
+                  <a:srgbClr val="EDEDED"/>
                 </a:solidFill>
                 <a:latin typeface="Inter"/>
               </a:rPr>
@@ -6079,7 +6099,7 @@
             <a:r>
               <a:rPr sz="1700" b="0">
                 <a:solidFill>
-                  <a:srgbClr val="F0F0F0"/>
+                  <a:srgbClr val="EDEDED"/>
                 </a:solidFill>
                 <a:latin typeface="Inter"/>
               </a:rPr>
@@ -6138,7 +6158,7 @@
             <a:r>
               <a:rPr sz="1000">
                 <a:solidFill>
-                  <a:srgbClr val="9A9A9A"/>
+                  <a:srgbClr val="A6A6A6"/>
                 </a:solidFill>
                 <a:latin typeface="Inter"/>
               </a:rPr>
@@ -6152,6 +6172,7 @@
   <p:clrMapOvr>
     <a:masterClrMapping/>
   </p:clrMapOvr>
+  <p:transition spd="med" fade="1"/>
 </p:sld>
 </file>
 
@@ -6223,7 +6244,7 @@
             <a:avLst/>
           </a:prstGeom>
           <a:solidFill>
-            <a:srgbClr val="A2391D"/>
+            <a:srgbClr val="D0603A"/>
           </a:solidFill>
           <a:ln>
             <a:noFill/>
@@ -6315,7 +6336,7 @@
             <a:r>
               <a:rPr sz="1700" b="0">
                 <a:solidFill>
-                  <a:srgbClr val="F0F0F0"/>
+                  <a:srgbClr val="EDEDED"/>
                 </a:solidFill>
                 <a:latin typeface="Inter"/>
               </a:rPr>
@@ -6331,7 +6352,7 @@
             <a:r>
               <a:rPr sz="1700" b="0">
                 <a:solidFill>
-                  <a:srgbClr val="F0F0F0"/>
+                  <a:srgbClr val="EDEDED"/>
                 </a:solidFill>
                 <a:latin typeface="Inter"/>
               </a:rPr>
@@ -6347,7 +6368,7 @@
             <a:r>
               <a:rPr sz="1700" b="0">
                 <a:solidFill>
-                  <a:srgbClr val="F0F0F0"/>
+                  <a:srgbClr val="EDEDED"/>
                 </a:solidFill>
                 <a:latin typeface="Inter"/>
               </a:rPr>
@@ -6363,7 +6384,7 @@
             <a:r>
               <a:rPr sz="1700" b="0">
                 <a:solidFill>
-                  <a:srgbClr val="F0F0F0"/>
+                  <a:srgbClr val="EDEDED"/>
                 </a:solidFill>
                 <a:latin typeface="Inter"/>
               </a:rPr>
@@ -6379,7 +6400,7 @@
             <a:r>
               <a:rPr sz="1700" b="0">
                 <a:solidFill>
-                  <a:srgbClr val="F0F0F0"/>
+                  <a:srgbClr val="EDEDED"/>
                 </a:solidFill>
                 <a:latin typeface="Inter"/>
               </a:rPr>
@@ -6418,7 +6439,7 @@
             <a:r>
               <a:rPr sz="1700" b="0">
                 <a:solidFill>
-                  <a:srgbClr val="F0F0F0"/>
+                  <a:srgbClr val="EDEDED"/>
                 </a:solidFill>
                 <a:latin typeface="Inter"/>
               </a:rPr>
@@ -6434,7 +6455,7 @@
             <a:r>
               <a:rPr sz="1700" b="0">
                 <a:solidFill>
-                  <a:srgbClr val="F0F0F0"/>
+                  <a:srgbClr val="EDEDED"/>
                 </a:solidFill>
                 <a:latin typeface="Inter"/>
               </a:rPr>
@@ -6452,7 +6473,7 @@
             <a:r>
               <a:rPr sz="1700" b="0">
                 <a:solidFill>
-                  <a:srgbClr val="F0F0F0"/>
+                  <a:srgbClr val="EDEDED"/>
                 </a:solidFill>
                 <a:latin typeface="Inter"/>
               </a:rPr>
@@ -6468,7 +6489,7 @@
             <a:r>
               <a:rPr sz="1700" b="0">
                 <a:solidFill>
-                  <a:srgbClr val="F0F0F0"/>
+                  <a:srgbClr val="EDEDED"/>
                 </a:solidFill>
                 <a:latin typeface="Inter"/>
               </a:rPr>
@@ -6502,7 +6523,7 @@
             <a:r>
               <a:rPr sz="1100" b="0">
                 <a:solidFill>
-                  <a:srgbClr val="9A9A9A"/>
+                  <a:srgbClr val="A6A6A6"/>
                 </a:solidFill>
                 <a:latin typeface="Inter"/>
               </a:rPr>
@@ -6537,7 +6558,7 @@
             <a:r>
               <a:rPr sz="1000">
                 <a:solidFill>
-                  <a:srgbClr val="9A9A9A"/>
+                  <a:srgbClr val="A6A6A6"/>
                 </a:solidFill>
                 <a:latin typeface="Inter"/>
               </a:rPr>
@@ -6551,6 +6572,7 @@
   <p:clrMapOvr>
     <a:masterClrMapping/>
   </p:clrMapOvr>
+  <p:transition spd="med" fade="1"/>
 </p:sld>
 </file>
 
@@ -6622,7 +6644,7 @@
             <a:avLst/>
           </a:prstGeom>
           <a:solidFill>
-            <a:srgbClr val="A2391D"/>
+            <a:srgbClr val="D0603A"/>
           </a:solidFill>
           <a:ln>
             <a:noFill/>
@@ -6720,7 +6742,7 @@
             <a:r>
               <a:rPr sz="1300" b="0">
                 <a:solidFill>
-                  <a:srgbClr val="B0B0B0"/>
+                  <a:srgbClr val="B8B8B8"/>
                 </a:solidFill>
                 <a:latin typeface="Inter"/>
               </a:rPr>
@@ -6765,7 +6787,7 @@
             <a:r>
               <a:rPr sz="1300" b="0">
                 <a:solidFill>
-                  <a:srgbClr val="B0B0B0"/>
+                  <a:srgbClr val="B8B8B8"/>
                 </a:solidFill>
                 <a:latin typeface="Inter"/>
               </a:rPr>
@@ -6810,7 +6832,7 @@
             <a:r>
               <a:rPr sz="1300" b="0">
                 <a:solidFill>
-                  <a:srgbClr val="B0B0B0"/>
+                  <a:srgbClr val="B8B8B8"/>
                 </a:solidFill>
                 <a:latin typeface="Inter"/>
               </a:rPr>
@@ -6855,7 +6877,7 @@
             <a:r>
               <a:rPr sz="1300" b="0">
                 <a:solidFill>
-                  <a:srgbClr val="B0B0B0"/>
+                  <a:srgbClr val="B8B8B8"/>
                 </a:solidFill>
                 <a:latin typeface="Inter"/>
               </a:rPr>
@@ -6900,7 +6922,7 @@
             <a:r>
               <a:rPr sz="1300" b="0">
                 <a:solidFill>
-                  <a:srgbClr val="B0B0B0"/>
+                  <a:srgbClr val="B8B8B8"/>
                 </a:solidFill>
                 <a:latin typeface="Inter"/>
               </a:rPr>
@@ -6945,7 +6967,7 @@
             <a:r>
               <a:rPr sz="1300" b="0">
                 <a:solidFill>
-                  <a:srgbClr val="B0B0B0"/>
+                  <a:srgbClr val="B8B8B8"/>
                 </a:solidFill>
                 <a:latin typeface="Inter"/>
               </a:rPr>
@@ -6971,7 +6993,7 @@
         <p:spPr>
           <a:xfrm>
             <a:off x="7429500" y="1554480"/>
-            <a:ext cx="4190694" cy="3213739"/>
+            <a:ext cx="4190695" cy="3211868"/>
           </a:xfrm>
           <a:prstGeom prst="rect">
             <a:avLst/>
@@ -7003,7 +7025,7 @@
             <a:r>
               <a:rPr sz="1100" b="0">
                 <a:solidFill>
-                  <a:srgbClr val="9A9A9A"/>
+                  <a:srgbClr val="A6A6A6"/>
                 </a:solidFill>
                 <a:latin typeface="Inter"/>
               </a:rPr>
@@ -7038,7 +7060,7 @@
             <a:r>
               <a:rPr sz="1000">
                 <a:solidFill>
-                  <a:srgbClr val="9A9A9A"/>
+                  <a:srgbClr val="A6A6A6"/>
                 </a:solidFill>
                 <a:latin typeface="Inter"/>
               </a:rPr>
@@ -7052,6 +7074,7 @@
   <p:clrMapOvr>
     <a:masterClrMapping/>
   </p:clrMapOvr>
+  <p:transition spd="med" fade="1"/>
 </p:sld>
 </file>
 
@@ -7123,7 +7146,7 @@
             <a:avLst/>
           </a:prstGeom>
           <a:solidFill>
-            <a:srgbClr val="A2391D"/>
+            <a:srgbClr val="D0603A"/>
           </a:solidFill>
           <a:ln>
             <a:noFill/>
@@ -7185,80 +7208,9 @@
           </a:p>
         </p:txBody>
       </p:sp>
-      <p:sp>
-        <p:nvSpPr>
-          <p:cNvPr id="5" name="TextBox 4"/>
-          <p:cNvSpPr txBox="1"/>
-          <p:nvPr/>
-        </p:nvSpPr>
-        <p:spPr>
-          <a:xfrm>
-            <a:off x="571500" y="1554480"/>
-            <a:ext cx="5394960" cy="3931920"/>
-          </a:xfrm>
-          <a:prstGeom prst="rect">
-            <a:avLst/>
-          </a:prstGeom>
-          <a:noFill/>
-        </p:spPr>
-        <p:txBody>
-          <a:bodyPr wrap="square" anchor="t">
-            <a:spAutoFit/>
-          </a:bodyPr>
-          <a:lstStyle/>
-          <a:p>
-            <a:pPr>
-              <a:spcAft>
-                <a:spcPts val="1000"/>
-              </a:spcAft>
-            </a:pPr>
-            <a:r>
-              <a:rPr sz="1700" b="0">
-                <a:solidFill>
-                  <a:srgbClr val="F0F0F0"/>
-                </a:solidFill>
-                <a:latin typeface="Inter"/>
-              </a:rPr>
-              <a:t>•  Ядро отделено от GUI контрактами JSON — веб тонкая обёртка, не дубль.</a:t>
-            </a:r>
-          </a:p>
-          <a:p>
-            <a:pPr>
-              <a:spcAft>
-                <a:spcPts val="1000"/>
-              </a:spcAft>
-            </a:pPr>
-            <a:r>
-              <a:rPr sz="1700" b="0">
-                <a:solidFill>
-                  <a:srgbClr val="F0F0F0"/>
-                </a:solidFill>
-                <a:latin typeface="Inter"/>
-              </a:rPr>
-              <a:t>•  Те же src.capture и src.protocol, своей логики нет.</a:t>
-            </a:r>
-          </a:p>
-          <a:p>
-            <a:pPr>
-              <a:spcAft>
-                <a:spcPts val="1000"/>
-              </a:spcAft>
-            </a:pPr>
-            <a:r>
-              <a:rPr sz="1700" b="0">
-                <a:solidFill>
-                  <a:srgbClr val="F0F0F0"/>
-                </a:solidFill>
-                <a:latin typeface="Inter"/>
-              </a:rPr>
-              <a:t>•  Ставится отдельно: pip install -e ".[web]".</a:t>
-            </a:r>
-          </a:p>
-        </p:txBody>
-      </p:sp>
       <p:pic>
         <p:nvPicPr>
-          <p:cNvPr id="6" name="Picture 5" descr="web.png"/>
+          <p:cNvPr id="5" name="Picture 4" descr="web.png"/>
           <p:cNvPicPr>
             <a:picLocks noChangeAspect="1"/>
           </p:cNvPicPr>
@@ -7272,24 +7224,24 @@
         </p:blipFill>
         <p:spPr>
           <a:xfrm>
+            <a:off x="571500" y="1554480"/>
+            <a:ext cx="2400300" cy="4114800"/>
+          </a:xfrm>
+          <a:prstGeom prst="rect">
+            <a:avLst/>
+          </a:prstGeom>
+        </p:spPr>
+      </p:pic>
+      <p:sp>
+        <p:nvSpPr>
+          <p:cNvPr id="6" name="TextBox 5"/>
+          <p:cNvSpPr txBox="1"/>
+          <p:nvPr/>
+        </p:nvSpPr>
+        <p:spPr>
+          <a:xfrm>
             <a:off x="6240780" y="1554480"/>
-            <a:ext cx="2400300" cy="4114800"/>
-          </a:xfrm>
-          <a:prstGeom prst="rect">
-            <a:avLst/>
-          </a:prstGeom>
-        </p:spPr>
-      </p:pic>
-      <p:sp>
-        <p:nvSpPr>
-          <p:cNvPr id="7" name="TextBox 6"/>
-          <p:cNvSpPr txBox="1"/>
-          <p:nvPr/>
-        </p:nvSpPr>
-        <p:spPr>
-          <a:xfrm>
-            <a:off x="571500" y="5989320"/>
-            <a:ext cx="11048695" cy="457200"/>
+            <a:ext cx="5379415" cy="3931920"/>
           </a:xfrm>
           <a:prstGeom prst="rect">
             <a:avLst/>
@@ -7302,28 +7254,65 @@
           </a:bodyPr>
           <a:lstStyle/>
           <a:p>
-            <a:r>
-              <a:rPr sz="1100" b="0">
-                <a:solidFill>
-                  <a:srgbClr val="9A9A9A"/>
+            <a:pPr>
+              <a:spcAft>
+                <a:spcPts val="1000"/>
+              </a:spcAft>
+            </a:pPr>
+            <a:r>
+              <a:rPr sz="1700" b="0">
+                <a:solidFill>
+                  <a:srgbClr val="EDEDED"/>
                 </a:solidFill>
                 <a:latin typeface="Inter"/>
               </a:rPr>
-              <a:t>FastAPI + HTMX, 127.0.0.1, extra .[web].</a:t>
-            </a:r>
-          </a:p>
-        </p:txBody>
-      </p:sp>
-      <p:sp>
-        <p:nvSpPr>
-          <p:cNvPr id="8" name="TextBox 7"/>
+              <a:t>•  Ядро отделено от GUI контрактами JSON — веб тонкая обёртка, не дубль.</a:t>
+            </a:r>
+          </a:p>
+          <a:p>
+            <a:pPr>
+              <a:spcAft>
+                <a:spcPts val="1000"/>
+              </a:spcAft>
+            </a:pPr>
+            <a:r>
+              <a:rPr sz="1700" b="0">
+                <a:solidFill>
+                  <a:srgbClr val="EDEDED"/>
+                </a:solidFill>
+                <a:latin typeface="Inter"/>
+              </a:rPr>
+              <a:t>•  Те же src.capture и src.protocol, своей логики нет.</a:t>
+            </a:r>
+          </a:p>
+          <a:p>
+            <a:pPr>
+              <a:spcAft>
+                <a:spcPts val="1000"/>
+              </a:spcAft>
+            </a:pPr>
+            <a:r>
+              <a:rPr sz="1700" b="0">
+                <a:solidFill>
+                  <a:srgbClr val="EDEDED"/>
+                </a:solidFill>
+                <a:latin typeface="Inter"/>
+              </a:rPr>
+              <a:t>•  Ставится отдельно: pip install -e ".[web]".</a:t>
+            </a:r>
+          </a:p>
+        </p:txBody>
+      </p:sp>
+      <p:sp>
+        <p:nvSpPr>
+          <p:cNvPr id="7" name="TextBox 6"/>
           <p:cNvSpPr txBox="1"/>
           <p:nvPr/>
         </p:nvSpPr>
         <p:spPr>
           <a:xfrm>
-            <a:off x="571500" y="6400800"/>
-            <a:ext cx="11048695" cy="274320"/>
+            <a:off x="571500" y="5989320"/>
+            <a:ext cx="11048695" cy="457200"/>
           </a:xfrm>
           <a:prstGeom prst="rect">
             <a:avLst/>
@@ -7336,11 +7325,45 @@
           </a:bodyPr>
           <a:lstStyle/>
           <a:p>
+            <a:r>
+              <a:rPr sz="1100" b="0">
+                <a:solidFill>
+                  <a:srgbClr val="A6A6A6"/>
+                </a:solidFill>
+                <a:latin typeface="Inter"/>
+              </a:rPr>
+              <a:t>FastAPI + HTMX, 127.0.0.1, extra .[web].</a:t>
+            </a:r>
+          </a:p>
+        </p:txBody>
+      </p:sp>
+      <p:sp>
+        <p:nvSpPr>
+          <p:cNvPr id="8" name="TextBox 7"/>
+          <p:cNvSpPr txBox="1"/>
+          <p:nvPr/>
+        </p:nvSpPr>
+        <p:spPr>
+          <a:xfrm>
+            <a:off x="571500" y="6400800"/>
+            <a:ext cx="11048695" cy="274320"/>
+          </a:xfrm>
+          <a:prstGeom prst="rect">
+            <a:avLst/>
+          </a:prstGeom>
+          <a:noFill/>
+        </p:spPr>
+        <p:txBody>
+          <a:bodyPr wrap="square" anchor="t">
+            <a:spAutoFit/>
+          </a:bodyPr>
+          <a:lstStyle/>
+          <a:p>
             <a:pPr algn="ctr"/>
             <a:r>
               <a:rPr sz="1000">
                 <a:solidFill>
-                  <a:srgbClr val="9A9A9A"/>
+                  <a:srgbClr val="A6A6A6"/>
                 </a:solidFill>
                 <a:latin typeface="Inter"/>
               </a:rPr>
@@ -7354,6 +7377,123 @@
   <p:clrMapOvr>
     <a:masterClrMapping/>
   </p:clrMapOvr>
+  <p:timing>
+    <p:tnLst>
+      <p:par>
+        <p:cTn id="1" dur="indefinite" restart="never" nodeType="tmRoot">
+          <p:childTnLst>
+            <p:seq concurrent="1" nextAc="seek">
+              <p:cTn id="2" dur="indefinite" nodeType="mainSeq">
+                <p:childTnLst>
+                  <p:par>
+                    <p:cTn id="3" presetID="10" presetClass="entr" presetSubtype="0" fill="hold" grpId="0" nodeType="clickEffect">
+                      <p:stCondLst>
+                        <p:cond delay="0"/>
+                      </p:stCondLst>
+                      <p:childTnLst>
+                        <p:set>
+                          <p:cBhvr>
+                            <p:cTn id="4" dur="1" fill="hold">
+                              <p:stCondLst>
+                                <p:cond delay="0"/>
+                              </p:stCondLst>
+                            </p:cTn>
+                            <p:tgtEl>
+                              <p:spTgt spid="5"/>
+                            </p:tgtEl>
+                            <p:attrNameLst>
+                              <p:attrName>style.visibility</p:attrName>
+                            </p:attrNameLst>
+                          </p:cBhvr>
+                          <p:to>
+                            <p:strVal val="visible"/>
+                          </p:to>
+                        </p:set>
+                        <p:anim calcmode="lin" valueType="num">
+                          <p:cBhvr additive="base">
+                            <p:cTn id="5" dur="500" fill="hold"/>
+                            <p:tgtEl>
+                              <p:spTgt spid="5"/>
+                            </p:tgtEl>
+                            <p:attrNameLst>
+                              <p:attrName>style.opacity</p:attrName>
+                            </p:attrNameLst>
+                          </p:cBhvr>
+                          <p:tavLst>
+                            <p:tav tm="0">
+                              <p:val>
+                                <p:fltVal val="0"/>
+                              </p:val>
+                            </p:tav>
+                            <p:tav tm="100000">
+                              <p:val>
+                                <p:fltVal val="1"/>
+                              </p:val>
+                            </p:tav>
+                          </p:tavLst>
+                        </p:anim>
+                      </p:childTnLst>
+                    </p:cTn>
+                  </p:par>
+                  <p:par>
+                    <p:cTn id="6" presetID="10" presetClass="entr" presetSubtype="0" fill="hold" grpId="0" nodeType="clickEffect">
+                      <p:stCondLst>
+                        <p:cond delay="0"/>
+                      </p:stCondLst>
+                      <p:childTnLst>
+                        <p:set>
+                          <p:cBhvr>
+                            <p:cTn id="7" dur="1" fill="hold">
+                              <p:stCondLst>
+                                <p:cond delay="0"/>
+                              </p:stCondLst>
+                            </p:cTn>
+                            <p:tgtEl>
+                              <p:spTgt spid="6"/>
+                            </p:tgtEl>
+                            <p:attrNameLst>
+                              <p:attrName>style.visibility</p:attrName>
+                            </p:attrNameLst>
+                          </p:cBhvr>
+                          <p:to>
+                            <p:strVal val="visible"/>
+                          </p:to>
+                        </p:set>
+                        <p:anim calcmode="lin" valueType="num">
+                          <p:cBhvr additive="base">
+                            <p:cTn id="8" dur="500" fill="hold"/>
+                            <p:tgtEl>
+                              <p:spTgt spid="6"/>
+                            </p:tgtEl>
+                            <p:attrNameLst>
+                              <p:attrName>style.opacity</p:attrName>
+                            </p:attrNameLst>
+                          </p:cBhvr>
+                          <p:tavLst>
+                            <p:tav tm="0">
+                              <p:val>
+                                <p:fltVal val="0"/>
+                              </p:val>
+                            </p:tav>
+                            <p:tav tm="100000">
+                              <p:val>
+                                <p:fltVal val="1"/>
+                              </p:val>
+                            </p:tav>
+                          </p:tavLst>
+                        </p:anim>
+                      </p:childTnLst>
+                    </p:cTn>
+                  </p:par>
+                </p:childTnLst>
+              </p:cTn>
+            </p:seq>
+          </p:childTnLst>
+        </p:cTn>
+      </p:par>
+    </p:tnLst>
+  </p:timing>
+  <p:transition spd="med" fade="1"/>
 </p:sld>
 </file>
 
@@ -7425,7 +7565,7 @@
             <a:avLst/>
           </a:prstGeom>
           <a:solidFill>
-            <a:srgbClr val="A2391D"/>
+            <a:srgbClr val="D0603A"/>
           </a:solidFill>
           <a:ln>
             <a:noFill/>
@@ -7536,7 +7676,7 @@
             <a:avLst/>
           </a:prstGeom>
           <a:solidFill>
-            <a:srgbClr val="A2391D"/>
+            <a:srgbClr val="D0603A"/>
           </a:solidFill>
           <a:ln>
             <a:noFill/>
@@ -7590,7 +7730,7 @@
             <a:r>
               <a:rPr sz="1000">
                 <a:solidFill>
-                  <a:srgbClr val="9A9A9A"/>
+                  <a:srgbClr val="A6A6A6"/>
                 </a:solidFill>
                 <a:latin typeface="Inter"/>
               </a:rPr>
@@ -7742,7 +7882,7 @@
             <a:avLst/>
           </a:prstGeom>
           <a:solidFill>
-            <a:srgbClr val="A2391D"/>
+            <a:srgbClr val="D0603A"/>
           </a:solidFill>
           <a:ln>
             <a:noFill/>
@@ -7834,7 +7974,7 @@
             <a:r>
               <a:rPr sz="1700" b="0">
                 <a:solidFill>
-                  <a:srgbClr val="F0F0F0"/>
+                  <a:srgbClr val="EDEDED"/>
                 </a:solidFill>
                 <a:latin typeface="Inter"/>
               </a:rPr>
@@ -7850,7 +7990,7 @@
             <a:r>
               <a:rPr sz="1700" b="0">
                 <a:solidFill>
-                  <a:srgbClr val="F0F0F0"/>
+                  <a:srgbClr val="EDEDED"/>
                 </a:solidFill>
                 <a:latin typeface="Inter"/>
               </a:rPr>
@@ -7866,7 +8006,7 @@
             <a:r>
               <a:rPr sz="1700" b="0">
                 <a:solidFill>
-                  <a:srgbClr val="F0F0F0"/>
+                  <a:srgbClr val="EDEDED"/>
                 </a:solidFill>
                 <a:latin typeface="Inter"/>
               </a:rPr>
@@ -7905,7 +8045,7 @@
             <a:r>
               <a:rPr sz="1700" b="0">
                 <a:solidFill>
-                  <a:srgbClr val="F0F0F0"/>
+                  <a:srgbClr val="EDEDED"/>
                 </a:solidFill>
                 <a:latin typeface="Inter"/>
               </a:rPr>
@@ -7921,7 +8061,7 @@
             <a:r>
               <a:rPr sz="1700" b="0">
                 <a:solidFill>
-                  <a:srgbClr val="F0F0F0"/>
+                  <a:srgbClr val="EDEDED"/>
                 </a:solidFill>
                 <a:latin typeface="Inter"/>
               </a:rPr>
@@ -7937,7 +8077,7 @@
             <a:r>
               <a:rPr sz="1700" b="0">
                 <a:solidFill>
-                  <a:srgbClr val="F0F0F0"/>
+                  <a:srgbClr val="EDEDED"/>
                 </a:solidFill>
                 <a:latin typeface="Inter"/>
               </a:rPr>
@@ -7972,7 +8112,7 @@
             <a:r>
               <a:rPr sz="1000">
                 <a:solidFill>
-                  <a:srgbClr val="9A9A9A"/>
+                  <a:srgbClr val="A6A6A6"/>
                 </a:solidFill>
                 <a:latin typeface="Inter"/>
               </a:rPr>
@@ -7986,6 +8126,7 @@
   <p:clrMapOvr>
     <a:masterClrMapping/>
   </p:clrMapOvr>
+  <p:transition spd="med" fade="1"/>
 </p:sld>
 </file>
 
@@ -8057,7 +8198,7 @@
             <a:avLst/>
           </a:prstGeom>
           <a:solidFill>
-            <a:srgbClr val="A2391D"/>
+            <a:srgbClr val="D0603A"/>
           </a:solidFill>
           <a:ln>
             <a:noFill/>
@@ -8173,7 +8314,7 @@
             <a:r>
               <a:rPr sz="1800" b="0">
                 <a:solidFill>
-                  <a:srgbClr val="F0F0F0"/>
+                  <a:srgbClr val="EDEDED"/>
                 </a:solidFill>
                 <a:latin typeface="Inter"/>
               </a:rPr>
@@ -8191,7 +8332,7 @@
             <a:r>
               <a:rPr sz="1800" b="0">
                 <a:solidFill>
-                  <a:srgbClr val="F0F0F0"/>
+                  <a:srgbClr val="EDEDED"/>
                 </a:solidFill>
                 <a:latin typeface="Inter"/>
               </a:rPr>
@@ -8207,7 +8348,7 @@
             <a:r>
               <a:rPr sz="1800" b="0">
                 <a:solidFill>
-                  <a:srgbClr val="F0F0F0"/>
+                  <a:srgbClr val="EDEDED"/>
                 </a:solidFill>
                 <a:latin typeface="Inter"/>
               </a:rPr>
@@ -8225,7 +8366,7 @@
             <a:r>
               <a:rPr sz="1800" b="0">
                 <a:solidFill>
-                  <a:srgbClr val="F0F0F0"/>
+                  <a:srgbClr val="EDEDED"/>
                 </a:solidFill>
                 <a:latin typeface="Inter"/>
               </a:rPr>
@@ -8259,7 +8400,7 @@
             <a:r>
               <a:rPr sz="1100" b="0">
                 <a:solidFill>
-                  <a:srgbClr val="9A9A9A"/>
+                  <a:srgbClr val="A6A6A6"/>
                 </a:solidFill>
                 <a:latin typeface="Inter"/>
               </a:rPr>
@@ -8294,7 +8435,7 @@
             <a:r>
               <a:rPr sz="1000">
                 <a:solidFill>
-                  <a:srgbClr val="9A9A9A"/>
+                  <a:srgbClr val="A6A6A6"/>
                 </a:solidFill>
                 <a:latin typeface="Inter"/>
               </a:rPr>
@@ -8308,6 +8449,7 @@
   <p:clrMapOvr>
     <a:masterClrMapping/>
   </p:clrMapOvr>
+  <p:transition spd="med" fade="1"/>
 </p:sld>
 </file>
 
@@ -8379,7 +8521,7 @@
             <a:avLst/>
           </a:prstGeom>
           <a:solidFill>
-            <a:srgbClr val="A2391D"/>
+            <a:srgbClr val="D0603A"/>
           </a:solidFill>
           <a:ln>
             <a:noFill/>
@@ -8471,7 +8613,7 @@
             <a:r>
               <a:rPr sz="1700" b="0">
                 <a:solidFill>
-                  <a:srgbClr val="F0F0F0"/>
+                  <a:srgbClr val="EDEDED"/>
                 </a:solidFill>
                 <a:latin typeface="Inter"/>
               </a:rPr>
@@ -8487,7 +8629,7 @@
             <a:r>
               <a:rPr sz="1700" b="0">
                 <a:solidFill>
-                  <a:srgbClr val="F0F0F0"/>
+                  <a:srgbClr val="EDEDED"/>
                 </a:solidFill>
                 <a:latin typeface="Inter"/>
               </a:rPr>
@@ -8526,7 +8668,7 @@
             <a:r>
               <a:rPr sz="1700" b="0">
                 <a:solidFill>
-                  <a:srgbClr val="F0F0F0"/>
+                  <a:srgbClr val="EDEDED"/>
                 </a:solidFill>
                 <a:latin typeface="Inter"/>
               </a:rPr>
@@ -8542,7 +8684,7 @@
             <a:r>
               <a:rPr sz="1700" b="0">
                 <a:solidFill>
-                  <a:srgbClr val="F0F0F0"/>
+                  <a:srgbClr val="EDEDED"/>
                 </a:solidFill>
                 <a:latin typeface="Inter"/>
               </a:rPr>
@@ -8576,7 +8718,7 @@
             <a:r>
               <a:rPr sz="1100" b="0">
                 <a:solidFill>
-                  <a:srgbClr val="9A9A9A"/>
+                  <a:srgbClr val="A6A6A6"/>
                 </a:solidFill>
                 <a:latin typeface="Inter"/>
               </a:rPr>
@@ -8611,7 +8753,7 @@
             <a:r>
               <a:rPr sz="1000">
                 <a:solidFill>
-                  <a:srgbClr val="9A9A9A"/>
+                  <a:srgbClr val="A6A6A6"/>
                 </a:solidFill>
                 <a:latin typeface="Inter"/>
               </a:rPr>
@@ -8625,6 +8767,7 @@
   <p:clrMapOvr>
     <a:masterClrMapping/>
   </p:clrMapOvr>
+  <p:transition spd="med" fade="1"/>
 </p:sld>
 </file>
 
@@ -8696,7 +8839,7 @@
             <a:avLst/>
           </a:prstGeom>
           <a:solidFill>
-            <a:srgbClr val="A2391D"/>
+            <a:srgbClr val="D0603A"/>
           </a:solidFill>
           <a:ln>
             <a:noFill/>
@@ -8788,7 +8931,7 @@
             <a:r>
               <a:rPr sz="1700" b="0">
                 <a:solidFill>
-                  <a:srgbClr val="F0F0F0"/>
+                  <a:srgbClr val="EDEDED"/>
                 </a:solidFill>
                 <a:latin typeface="Inter"/>
               </a:rPr>
@@ -8804,7 +8947,7 @@
             <a:r>
               <a:rPr sz="1700" b="0">
                 <a:solidFill>
-                  <a:srgbClr val="F0F0F0"/>
+                  <a:srgbClr val="EDEDED"/>
                 </a:solidFill>
                 <a:latin typeface="Inter"/>
               </a:rPr>
@@ -8820,7 +8963,7 @@
             <a:r>
               <a:rPr sz="1700" b="0">
                 <a:solidFill>
-                  <a:srgbClr val="F0F0F0"/>
+                  <a:srgbClr val="EDEDED"/>
                 </a:solidFill>
                 <a:latin typeface="Inter"/>
               </a:rPr>
@@ -8836,7 +8979,7 @@
             <a:r>
               <a:rPr sz="1700" b="0">
                 <a:solidFill>
-                  <a:srgbClr val="F0F0F0"/>
+                  <a:srgbClr val="EDEDED"/>
                 </a:solidFill>
                 <a:latin typeface="Inter"/>
               </a:rPr>
@@ -8895,7 +9038,7 @@
             <a:r>
               <a:rPr sz="1100">
                 <a:solidFill>
-                  <a:srgbClr val="9A9A9A"/>
+                  <a:srgbClr val="A6A6A6"/>
                 </a:solidFill>
                 <a:hlinkClick r:id="rId3"/>
               </a:rPr>
@@ -8930,7 +9073,7 @@
             <a:r>
               <a:rPr sz="1000">
                 <a:solidFill>
-                  <a:srgbClr val="9A9A9A"/>
+                  <a:srgbClr val="A6A6A6"/>
                 </a:solidFill>
                 <a:latin typeface="Inter"/>
               </a:rPr>
@@ -8944,6 +9087,7 @@
   <p:clrMapOvr>
     <a:masterClrMapping/>
   </p:clrMapOvr>
+  <p:transition spd="med" fade="1"/>
 </p:sld>
 </file>
 
@@ -9015,7 +9159,7 @@
             <a:avLst/>
           </a:prstGeom>
           <a:solidFill>
-            <a:srgbClr val="A2391D"/>
+            <a:srgbClr val="D0603A"/>
           </a:solidFill>
           <a:ln>
             <a:noFill/>
@@ -9051,8 +9195,8 @@
         </p:nvSpPr>
         <p:spPr>
           <a:xfrm>
-            <a:off x="571500" y="2743200"/>
-            <a:ext cx="11048695" cy="1097280"/>
+            <a:off x="571500" y="1371600"/>
+            <a:ext cx="11048695" cy="914400"/>
           </a:xfrm>
           <a:prstGeom prst="rect">
             <a:avLst/>
@@ -9085,8 +9229,8 @@
         </p:nvSpPr>
         <p:spPr>
           <a:xfrm>
-            <a:off x="571500" y="3840480"/>
-            <a:ext cx="11048695" cy="731520"/>
+            <a:off x="571500" y="2377440"/>
+            <a:ext cx="11048695" cy="548640"/>
           </a:xfrm>
           <a:prstGeom prst="rect">
             <a:avLst/>
@@ -9102,7 +9246,7 @@
             <a:r>
               <a:rPr sz="1800" b="0">
                 <a:solidFill>
-                  <a:srgbClr val="B0B0B0"/>
+                  <a:srgbClr val="B8B8B8"/>
                 </a:solidFill>
                 <a:latin typeface="Inter"/>
               </a:rPr>
@@ -9119,8 +9263,8 @@
         </p:nvSpPr>
         <p:spPr>
           <a:xfrm>
-            <a:off x="571500" y="4572000"/>
-            <a:ext cx="11048695" cy="548640"/>
+            <a:off x="571500" y="3017520"/>
+            <a:ext cx="3439058" cy="914400"/>
           </a:xfrm>
           <a:prstGeom prst="rect">
             <a:avLst/>
@@ -9133,14 +9277,27 @@
           </a:bodyPr>
           <a:lstStyle/>
           <a:p>
-            <a:r>
-              <a:rPr sz="1400">
-                <a:solidFill>
-                  <a:srgbClr val="E0603A"/>
-                </a:solidFill>
-                <a:hlinkClick r:id="rId2"/>
-              </a:rPr>
-              <a:t>https://github.com/Pavel1778/madrigal-protocol-lab</a:t>
+            <a:pPr algn="ctr"/>
+            <a:r>
+              <a:rPr sz="3000" b="0">
+                <a:solidFill>
+                  <a:srgbClr val="FFFFFF"/>
+                </a:solidFill>
+                <a:latin typeface="Manrope"/>
+              </a:rPr>
+              <a:t>741</a:t>
+            </a:r>
+          </a:p>
+          <a:p>
+            <a:pPr algn="ctr"/>
+            <a:r>
+              <a:rPr sz="1200" b="0">
+                <a:solidFill>
+                  <a:srgbClr val="B8B8B8"/>
+                </a:solidFill>
+                <a:latin typeface="Inter"/>
+              </a:rPr>
+              <a:t>тест</a:t>
             </a:r>
           </a:p>
         </p:txBody>
@@ -9153,8 +9310,8 @@
         </p:nvSpPr>
         <p:spPr>
           <a:xfrm>
-            <a:off x="571500" y="6400800"/>
-            <a:ext cx="11048695" cy="274320"/>
+            <a:off x="4376318" y="3017520"/>
+            <a:ext cx="3439058" cy="914400"/>
           </a:xfrm>
           <a:prstGeom prst="rect">
             <a:avLst/>
@@ -9169,9 +9326,221 @@
           <a:p>
             <a:pPr algn="ctr"/>
             <a:r>
+              <a:rPr sz="3000" b="0">
+                <a:solidFill>
+                  <a:srgbClr val="FFFFFF"/>
+                </a:solidFill>
+                <a:latin typeface="Manrope"/>
+              </a:rPr>
+              <a:t>90%</a:t>
+            </a:r>
+          </a:p>
+          <a:p>
+            <a:pPr algn="ctr"/>
+            <a:r>
+              <a:rPr sz="1200" b="0">
+                <a:solidFill>
+                  <a:srgbClr val="B8B8B8"/>
+                </a:solidFill>
+                <a:latin typeface="Inter"/>
+              </a:rPr>
+              <a:t>покрытие</a:t>
+            </a:r>
+          </a:p>
+        </p:txBody>
+      </p:sp>
+      <p:sp>
+        <p:nvSpPr>
+          <p:cNvPr id="8" name="TextBox 7"/>
+          <p:cNvSpPr txBox="1"/>
+          <p:nvPr/>
+        </p:nvSpPr>
+        <p:spPr>
+          <a:xfrm>
+            <a:off x="8181136" y="3017520"/>
+            <a:ext cx="3439058" cy="914400"/>
+          </a:xfrm>
+          <a:prstGeom prst="rect">
+            <a:avLst/>
+          </a:prstGeom>
+          <a:noFill/>
+        </p:spPr>
+        <p:txBody>
+          <a:bodyPr wrap="square" anchor="t">
+            <a:spAutoFit/>
+          </a:bodyPr>
+          <a:lstStyle/>
+          <a:p>
+            <a:pPr algn="ctr"/>
+            <a:r>
+              <a:rPr sz="3000" b="0">
+                <a:solidFill>
+                  <a:srgbClr val="FFFFFF"/>
+                </a:solidFill>
+                <a:latin typeface="Manrope"/>
+              </a:rPr>
+              <a:t>8</a:t>
+            </a:r>
+          </a:p>
+          <a:p>
+            <a:pPr algn="ctr"/>
+            <a:r>
+              <a:rPr sz="1200" b="0">
+                <a:solidFill>
+                  <a:srgbClr val="B8B8B8"/>
+                </a:solidFill>
+                <a:latin typeface="Inter"/>
+              </a:rPr>
+              <a:t>артефактов в релизе</a:t>
+            </a:r>
+          </a:p>
+        </p:txBody>
+      </p:sp>
+      <p:pic>
+        <p:nvPicPr>
+          <p:cNvPr id="9" name="Picture 8" descr="qr_repo.png"/>
+          <p:cNvPicPr>
+            <a:picLocks noChangeAspect="1"/>
+          </p:cNvPicPr>
+          <p:nvPr/>
+        </p:nvPicPr>
+        <p:blipFill>
+          <a:blip r:embed="rId2"/>
+          <a:stretch>
+            <a:fillRect/>
+          </a:stretch>
+        </p:blipFill>
+        <p:spPr>
+          <a:xfrm>
+            <a:off x="4084167" y="4206240"/>
+            <a:ext cx="1463040" cy="1463040"/>
+          </a:xfrm>
+          <a:prstGeom prst="rect">
+            <a:avLst/>
+          </a:prstGeom>
+        </p:spPr>
+      </p:pic>
+      <p:sp>
+        <p:nvSpPr>
+          <p:cNvPr id="10" name="TextBox 9"/>
+          <p:cNvSpPr txBox="1"/>
+          <p:nvPr/>
+        </p:nvSpPr>
+        <p:spPr>
+          <a:xfrm>
+            <a:off x="3718407" y="5760720"/>
+            <a:ext cx="2194560" cy="320040"/>
+          </a:xfrm>
+          <a:prstGeom prst="rect">
+            <a:avLst/>
+          </a:prstGeom>
+          <a:noFill/>
+        </p:spPr>
+        <p:txBody>
+          <a:bodyPr wrap="square" anchor="t">
+            <a:spAutoFit/>
+          </a:bodyPr>
+          <a:lstStyle/>
+          <a:p>
+            <a:pPr algn="ctr"/>
+            <a:r>
+              <a:rPr sz="1100" b="0">
+                <a:solidFill>
+                  <a:srgbClr val="A6A6A6"/>
+                </a:solidFill>
+                <a:latin typeface="Inter"/>
+              </a:rPr>
+              <a:t>Репозиторий</a:t>
+            </a:r>
+          </a:p>
+        </p:txBody>
+      </p:sp>
+      <p:pic>
+        <p:nvPicPr>
+          <p:cNvPr id="11" name="Picture 10" descr="qr_release.png"/>
+          <p:cNvPicPr>
+            <a:picLocks noChangeAspect="1"/>
+          </p:cNvPicPr>
+          <p:nvPr/>
+        </p:nvPicPr>
+        <p:blipFill>
+          <a:blip r:embed="rId3"/>
+          <a:stretch>
+            <a:fillRect/>
+          </a:stretch>
+        </p:blipFill>
+        <p:spPr>
+          <a:xfrm>
+            <a:off x="6644487" y="4206240"/>
+            <a:ext cx="1463040" cy="1463040"/>
+          </a:xfrm>
+          <a:prstGeom prst="rect">
+            <a:avLst/>
+          </a:prstGeom>
+        </p:spPr>
+      </p:pic>
+      <p:sp>
+        <p:nvSpPr>
+          <p:cNvPr id="12" name="TextBox 11"/>
+          <p:cNvSpPr txBox="1"/>
+          <p:nvPr/>
+        </p:nvSpPr>
+        <p:spPr>
+          <a:xfrm>
+            <a:off x="6278727" y="5760720"/>
+            <a:ext cx="2194560" cy="320040"/>
+          </a:xfrm>
+          <a:prstGeom prst="rect">
+            <a:avLst/>
+          </a:prstGeom>
+          <a:noFill/>
+        </p:spPr>
+        <p:txBody>
+          <a:bodyPr wrap="square" anchor="t">
+            <a:spAutoFit/>
+          </a:bodyPr>
+          <a:lstStyle/>
+          <a:p>
+            <a:pPr algn="ctr"/>
+            <a:r>
+              <a:rPr sz="1100" b="0">
+                <a:solidFill>
+                  <a:srgbClr val="A6A6A6"/>
+                </a:solidFill>
+                <a:latin typeface="Inter"/>
+              </a:rPr>
+              <a:t>Релиз v1.0.0</a:t>
+            </a:r>
+          </a:p>
+        </p:txBody>
+      </p:sp>
+      <p:sp>
+        <p:nvSpPr>
+          <p:cNvPr id="13" name="TextBox 12"/>
+          <p:cNvSpPr txBox="1"/>
+          <p:nvPr/>
+        </p:nvSpPr>
+        <p:spPr>
+          <a:xfrm>
+            <a:off x="571500" y="6400800"/>
+            <a:ext cx="11048695" cy="274320"/>
+          </a:xfrm>
+          <a:prstGeom prst="rect">
+            <a:avLst/>
+          </a:prstGeom>
+          <a:noFill/>
+        </p:spPr>
+        <p:txBody>
+          <a:bodyPr wrap="square" anchor="t">
+            <a:spAutoFit/>
+          </a:bodyPr>
+          <a:lstStyle/>
+          <a:p>
+            <a:pPr algn="ctr"/>
+            <a:r>
               <a:rPr sz="1000">
                 <a:solidFill>
-                  <a:srgbClr val="9A9A9A"/>
+                  <a:srgbClr val="A6A6A6"/>
                 </a:solidFill>
                 <a:latin typeface="Inter"/>
               </a:rPr>
@@ -9185,6 +9554,7 @@
   <p:clrMapOvr>
     <a:masterClrMapping/>
   </p:clrMapOvr>
+  <p:transition spd="med" fade="1"/>
 </p:sld>
 </file>
 
@@ -9256,7 +9626,7 @@
             <a:avLst/>
           </a:prstGeom>
           <a:solidFill>
-            <a:srgbClr val="A2391D"/>
+            <a:srgbClr val="D0603A"/>
           </a:solidFill>
           <a:ln>
             <a:noFill/>
@@ -9348,7 +9718,7 @@
             <a:r>
               <a:rPr sz="1700" b="0">
                 <a:solidFill>
-                  <a:srgbClr val="F0F0F0"/>
+                  <a:srgbClr val="EDEDED"/>
                 </a:solidFill>
                 <a:latin typeface="Inter"/>
               </a:rPr>
@@ -9366,7 +9736,7 @@
             <a:r>
               <a:rPr sz="1700" b="0">
                 <a:solidFill>
-                  <a:srgbClr val="F0F0F0"/>
+                  <a:srgbClr val="EDEDED"/>
                 </a:solidFill>
                 <a:latin typeface="Inter"/>
               </a:rPr>
@@ -9382,7 +9752,7 @@
             <a:r>
               <a:rPr sz="1700" b="0">
                 <a:solidFill>
-                  <a:srgbClr val="F0F0F0"/>
+                  <a:srgbClr val="EDEDED"/>
                 </a:solidFill>
                 <a:latin typeface="Inter"/>
               </a:rPr>
@@ -9400,7 +9770,7 @@
             <a:r>
               <a:rPr sz="1700" b="0">
                 <a:solidFill>
-                  <a:srgbClr val="F0F0F0"/>
+                  <a:srgbClr val="EDEDED"/>
                 </a:solidFill>
                 <a:latin typeface="Inter"/>
               </a:rPr>
@@ -9416,7 +9786,7 @@
             <a:r>
               <a:rPr sz="1700" b="0">
                 <a:solidFill>
-                  <a:srgbClr val="F0F0F0"/>
+                  <a:srgbClr val="EDEDED"/>
                 </a:solidFill>
                 <a:latin typeface="Inter"/>
               </a:rPr>
@@ -9434,7 +9804,7 @@
             <a:r>
               <a:rPr sz="1700" b="0">
                 <a:solidFill>
-                  <a:srgbClr val="F0F0F0"/>
+                  <a:srgbClr val="EDEDED"/>
                 </a:solidFill>
                 <a:latin typeface="Inter"/>
               </a:rPr>
@@ -9473,7 +9843,7 @@
             <a:r>
               <a:rPr sz="1700" b="0">
                 <a:solidFill>
-                  <a:srgbClr val="F0F0F0"/>
+                  <a:srgbClr val="EDEDED"/>
                 </a:solidFill>
                 <a:latin typeface="Inter"/>
               </a:rPr>
@@ -9489,7 +9859,7 @@
             <a:r>
               <a:rPr sz="1700" b="0">
                 <a:solidFill>
-                  <a:srgbClr val="F0F0F0"/>
+                  <a:srgbClr val="EDEDED"/>
                 </a:solidFill>
                 <a:latin typeface="Inter"/>
               </a:rPr>
@@ -9523,7 +9893,7 @@
             <a:r>
               <a:rPr sz="1100" b="0">
                 <a:solidFill>
-                  <a:srgbClr val="9A9A9A"/>
+                  <a:srgbClr val="A6A6A6"/>
                 </a:solidFill>
                 <a:latin typeface="Inter"/>
               </a:rPr>
@@ -9558,7 +9928,7 @@
             <a:r>
               <a:rPr sz="1000">
                 <a:solidFill>
-                  <a:srgbClr val="9A9A9A"/>
+                  <a:srgbClr val="A6A6A6"/>
                 </a:solidFill>
                 <a:latin typeface="Inter"/>
               </a:rPr>
@@ -9572,6 +9942,7 @@
   <p:clrMapOvr>
     <a:masterClrMapping/>
   </p:clrMapOvr>
+  <p:transition spd="med" fade="1"/>
 </p:sld>
 </file>
 
@@ -9643,7 +10014,7 @@
             <a:avLst/>
           </a:prstGeom>
           <a:solidFill>
-            <a:srgbClr val="A2391D"/>
+            <a:srgbClr val="D0603A"/>
           </a:solidFill>
           <a:ln>
             <a:noFill/>
@@ -9754,7 +10125,7 @@
             <a:avLst/>
           </a:prstGeom>
           <a:solidFill>
-            <a:srgbClr val="A2391D"/>
+            <a:srgbClr val="D0603A"/>
           </a:solidFill>
           <a:ln>
             <a:noFill/>
@@ -9808,7 +10179,7 @@
             <a:r>
               <a:rPr sz="1000">
                 <a:solidFill>
-                  <a:srgbClr val="9A9A9A"/>
+                  <a:srgbClr val="A6A6A6"/>
                 </a:solidFill>
                 <a:latin typeface="Inter"/>
               </a:rPr>
@@ -9960,7 +10331,7 @@
             <a:avLst/>
           </a:prstGeom>
           <a:solidFill>
-            <a:srgbClr val="A2391D"/>
+            <a:srgbClr val="D0603A"/>
           </a:solidFill>
           <a:ln>
             <a:noFill/>
@@ -10039,7 +10410,7 @@
         <p:spPr>
           <a:xfrm>
             <a:off x="571500" y="1554480"/>
-            <a:ext cx="8770267" cy="4023359"/>
+            <a:ext cx="11048695" cy="3914394"/>
           </a:xfrm>
           <a:prstGeom prst="rect">
             <a:avLst/>
@@ -10071,11 +10442,11 @@
             <a:r>
               <a:rPr sz="1100" b="0">
                 <a:solidFill>
-                  <a:srgbClr val="9A9A9A"/>
+                  <a:srgbClr val="A6A6A6"/>
                 </a:solidFill>
                 <a:latin typeface="Inter"/>
               </a:rPr>
-              <a:t>capture · protocol + hypothesis · ui. Контракты зафиксированы JSON Schema draft 2020-12.</a:t>
+              <a:t>Контракты зафиксированы JSON Schema (draft 2020-12) и не меняются молча.</a:t>
             </a:r>
           </a:p>
         </p:txBody>
@@ -10106,7 +10477,7 @@
             <a:r>
               <a:rPr sz="1000">
                 <a:solidFill>
-                  <a:srgbClr val="9A9A9A"/>
+                  <a:srgbClr val="A6A6A6"/>
                 </a:solidFill>
                 <a:latin typeface="Inter"/>
               </a:rPr>
@@ -10120,6 +10491,7 @@
   <p:clrMapOvr>
     <a:masterClrMapping/>
   </p:clrMapOvr>
+  <p:transition spd="med" fade="1"/>
 </p:sld>
 </file>
 
@@ -10191,7 +10563,7 @@
             <a:avLst/>
           </a:prstGeom>
           <a:solidFill>
-            <a:srgbClr val="A2391D"/>
+            <a:srgbClr val="D0603A"/>
           </a:solidFill>
           <a:ln>
             <a:noFill/>
@@ -10302,7 +10674,7 @@
             <a:avLst/>
           </a:prstGeom>
           <a:solidFill>
-            <a:srgbClr val="A2391D"/>
+            <a:srgbClr val="D0603A"/>
           </a:solidFill>
           <a:ln>
             <a:noFill/>
@@ -10356,7 +10728,7 @@
             <a:r>
               <a:rPr sz="1000">
                 <a:solidFill>
-                  <a:srgbClr val="9A9A9A"/>
+                  <a:srgbClr val="A6A6A6"/>
                 </a:solidFill>
                 <a:latin typeface="Inter"/>
               </a:rPr>
@@ -10508,7 +10880,7 @@
             <a:avLst/>
           </a:prstGeom>
           <a:solidFill>
-            <a:srgbClr val="A2391D"/>
+            <a:srgbClr val="D0603A"/>
           </a:solidFill>
           <a:ln>
             <a:noFill/>
@@ -10600,7 +10972,7 @@
             <a:r>
               <a:rPr sz="1700" b="0">
                 <a:solidFill>
-                  <a:srgbClr val="F0F0F0"/>
+                  <a:srgbClr val="EDEDED"/>
                 </a:solidFill>
                 <a:latin typeface="Inter"/>
               </a:rPr>
@@ -10616,7 +10988,7 @@
             <a:r>
               <a:rPr sz="1700" b="0">
                 <a:solidFill>
-                  <a:srgbClr val="F0F0F0"/>
+                  <a:srgbClr val="EDEDED"/>
                 </a:solidFill>
                 <a:latin typeface="Inter"/>
               </a:rPr>
@@ -10632,7 +11004,7 @@
             <a:r>
               <a:rPr sz="1700" b="0">
                 <a:solidFill>
-                  <a:srgbClr val="F0F0F0"/>
+                  <a:srgbClr val="EDEDED"/>
                 </a:solidFill>
                 <a:latin typeface="Inter"/>
               </a:rPr>
@@ -10648,7 +11020,7 @@
             <a:r>
               <a:rPr sz="1700" b="0">
                 <a:solidFill>
-                  <a:srgbClr val="F0F0F0"/>
+                  <a:srgbClr val="EDEDED"/>
                 </a:solidFill>
                 <a:latin typeface="Inter"/>
               </a:rPr>
@@ -10706,7 +11078,7 @@
             <a:r>
               <a:rPr sz="1100" b="0">
                 <a:solidFill>
-                  <a:srgbClr val="9A9A9A"/>
+                  <a:srgbClr val="A6A6A6"/>
                 </a:solidFill>
                 <a:latin typeface="Inter"/>
               </a:rPr>
@@ -10741,7 +11113,7 @@
             <a:r>
               <a:rPr sz="1000">
                 <a:solidFill>
-                  <a:srgbClr val="9A9A9A"/>
+                  <a:srgbClr val="A6A6A6"/>
                 </a:solidFill>
                 <a:latin typeface="Inter"/>
               </a:rPr>
@@ -10755,6 +11127,7 @@
   <p:clrMapOvr>
     <a:masterClrMapping/>
   </p:clrMapOvr>
+  <p:transition spd="med" fade="1"/>
 </p:sld>
 </file>
 
@@ -10826,7 +11199,7 @@
             <a:avLst/>
           </a:prstGeom>
           <a:solidFill>
-            <a:srgbClr val="A2391D"/>
+            <a:srgbClr val="D0603A"/>
           </a:solidFill>
           <a:ln>
             <a:noFill/>
@@ -10918,7 +11291,7 @@
             <a:r>
               <a:rPr sz="1700" b="0">
                 <a:solidFill>
-                  <a:srgbClr val="F0F0F0"/>
+                  <a:srgbClr val="EDEDED"/>
                 </a:solidFill>
                 <a:latin typeface="Inter"/>
               </a:rPr>
@@ -10934,7 +11307,7 @@
             <a:r>
               <a:rPr sz="1700" b="0">
                 <a:solidFill>
-                  <a:srgbClr val="F0F0F0"/>
+                  <a:srgbClr val="EDEDED"/>
                 </a:solidFill>
                 <a:latin typeface="Inter"/>
               </a:rPr>
@@ -10950,7 +11323,7 @@
             <a:r>
               <a:rPr sz="1700" b="0">
                 <a:solidFill>
-                  <a:srgbClr val="F0F0F0"/>
+                  <a:srgbClr val="EDEDED"/>
                 </a:solidFill>
                 <a:latin typeface="Inter"/>
               </a:rPr>
@@ -10968,7 +11341,7 @@
             <a:r>
               <a:rPr sz="1700" b="0">
                 <a:solidFill>
-                  <a:srgbClr val="F0F0F0"/>
+                  <a:srgbClr val="EDEDED"/>
                 </a:solidFill>
                 <a:latin typeface="Inter"/>
               </a:rPr>
@@ -10984,7 +11357,7 @@
             <a:r>
               <a:rPr sz="1700" b="0">
                 <a:solidFill>
-                  <a:srgbClr val="F0F0F0"/>
+                  <a:srgbClr val="EDEDED"/>
                 </a:solidFill>
                 <a:latin typeface="Inter"/>
               </a:rPr>
@@ -11023,7 +11396,7 @@
             <a:r>
               <a:rPr sz="1700" b="0">
                 <a:solidFill>
-                  <a:srgbClr val="F0F0F0"/>
+                  <a:srgbClr val="EDEDED"/>
                 </a:solidFill>
                 <a:latin typeface="Inter"/>
               </a:rPr>
@@ -11039,7 +11412,7 @@
             <a:r>
               <a:rPr sz="1700" b="0">
                 <a:solidFill>
-                  <a:srgbClr val="F0F0F0"/>
+                  <a:srgbClr val="EDEDED"/>
                 </a:solidFill>
                 <a:latin typeface="Inter"/>
               </a:rPr>
@@ -11055,7 +11428,7 @@
             <a:r>
               <a:rPr sz="1700" b="0">
                 <a:solidFill>
-                  <a:srgbClr val="F0F0F0"/>
+                  <a:srgbClr val="EDEDED"/>
                 </a:solidFill>
                 <a:latin typeface="Inter"/>
               </a:rPr>
@@ -11089,7 +11462,7 @@
             <a:r>
               <a:rPr sz="1100" b="0">
                 <a:solidFill>
-                  <a:srgbClr val="9A9A9A"/>
+                  <a:srgbClr val="A6A6A6"/>
                 </a:solidFill>
                 <a:latin typeface="Inter"/>
               </a:rPr>
@@ -11124,7 +11497,7 @@
             <a:r>
               <a:rPr sz="1000">
                 <a:solidFill>
-                  <a:srgbClr val="9A9A9A"/>
+                  <a:srgbClr val="A6A6A6"/>
                 </a:solidFill>
                 <a:latin typeface="Inter"/>
               </a:rPr>
@@ -11138,6 +11511,7 @@
   <p:clrMapOvr>
     <a:masterClrMapping/>
   </p:clrMapOvr>
+  <p:transition spd="med" fade="1"/>
 </p:sld>
 </file>
 
@@ -11209,7 +11583,7 @@
             <a:avLst/>
           </a:prstGeom>
           <a:solidFill>
-            <a:srgbClr val="A2391D"/>
+            <a:srgbClr val="D0603A"/>
           </a:solidFill>
           <a:ln>
             <a:noFill/>
@@ -11301,7 +11675,7 @@
             <a:r>
               <a:rPr sz="1700" b="0">
                 <a:solidFill>
-                  <a:srgbClr val="F0F0F0"/>
+                  <a:srgbClr val="EDEDED"/>
                 </a:solidFill>
                 <a:latin typeface="Inter"/>
               </a:rPr>
@@ -11317,7 +11691,7 @@
             <a:r>
               <a:rPr sz="1700" b="0">
                 <a:solidFill>
-                  <a:srgbClr val="F0F0F0"/>
+                  <a:srgbClr val="EDEDED"/>
                 </a:solidFill>
                 <a:latin typeface="Inter"/>
               </a:rPr>
@@ -11335,7 +11709,7 @@
             <a:r>
               <a:rPr sz="1700" b="0">
                 <a:solidFill>
-                  <a:srgbClr val="F0F0F0"/>
+                  <a:srgbClr val="EDEDED"/>
                 </a:solidFill>
                 <a:latin typeface="Inter"/>
               </a:rPr>
@@ -11351,7 +11725,7 @@
             <a:r>
               <a:rPr sz="1700" b="0">
                 <a:solidFill>
-                  <a:srgbClr val="F0F0F0"/>
+                  <a:srgbClr val="EDEDED"/>
                 </a:solidFill>
                 <a:latin typeface="Inter"/>
               </a:rPr>
@@ -11367,7 +11741,7 @@
             <a:r>
               <a:rPr sz="1700" b="0">
                 <a:solidFill>
-                  <a:srgbClr val="F0F0F0"/>
+                  <a:srgbClr val="EDEDED"/>
                 </a:solidFill>
                 <a:latin typeface="Inter"/>
               </a:rPr>
@@ -11426,7 +11800,7 @@
             <a:r>
               <a:rPr sz="1000">
                 <a:solidFill>
-                  <a:srgbClr val="9A9A9A"/>
+                  <a:srgbClr val="A6A6A6"/>
                 </a:solidFill>
                 <a:latin typeface="Inter"/>
               </a:rPr>
@@ -11440,6 +11814,7 @@
   <p:clrMapOvr>
     <a:masterClrMapping/>
   </p:clrMapOvr>
+  <p:transition spd="med" fade="1"/>
 </p:sld>
 </file>
 

</xml_diff>

<commit_message>
fix(presentation): finalize defence deck — fonts, sizes, sixth chain step
Sync the full redesign across every artifact after the review feedback.

- Real member photos 1.jpg/2.jpg as two distinct avatars (test asserts
  distinct bytes); avatar 180px, name 28px, QR 80px in CSS and PPTX.
- Sixth chain step «повторная проверка» in slides.md and the PPTX spec.
- Embed the brand fonts (Tektur/Montserrat/JetBrains Mono) so PowerPoint
  keeps the design; theme fonts move off Calibri.
- Reconcile slide 13: 350 MiB peak is 9% of the 4 GiB budget, 16 GiB machine.
- Rebuild both PDFs, the PPTX, the HTML bundle and checksums.txt.
- Layout verification clean on both PDFs; docs (README, VIDEO, CHANGELOG,
  PRESENTATION_VERIFICATION) updated.
</commit_message>
<xml_diff>
--- a/presentation/slides.pptx
+++ b/presentation/slides.pptx
@@ -1,6 +1,6 @@
 
 <file path=ppt/presentation.xml><?xml version="1.0" encoding="utf-8"?>
-<p:presentation xmlns:a="http://schemas.openxmlformats.org/drawingml/2006/main" xmlns:r="http://schemas.openxmlformats.org/officeDocument/2006/relationships" xmlns:p="http://schemas.openxmlformats.org/presentationml/2006/main" saveSubsetFonts="1" autoCompressPictures="0">
+<p:presentation xmlns:a="http://schemas.openxmlformats.org/drawingml/2006/main" xmlns:r="http://schemas.openxmlformats.org/officeDocument/2006/relationships" xmlns:p="http://schemas.openxmlformats.org/presentationml/2006/main" saveSubsetFonts="1" autoCompressPictures="0" embedTrueTypeFonts="1">
   <p:sldMasterIdLst>
     <p:sldMasterId id="2147483648" r:id="rId1"/>
   </p:sldMasterIdLst>
@@ -122,6 +122,22 @@
       </a:defRPr>
     </a:lvl9pPr>
   </p:defaultTextStyle>
+  <p:embeddedFontLst>
+    <p:embeddedFont>
+      <p:font typeface="Tektur"/>
+      <p:regular r:id="rId27" fontKey="{27E04CAF-4F9E-C315-3E78-7ADC5AE0D597}"/>
+      <p:bold r:id="rId28" fontKey="{A12660F0-7690-25AC-9BE9-6509C0A8B2A5}"/>
+    </p:embeddedFont>
+    <p:embeddedFont>
+      <p:font typeface="Montserrat"/>
+      <p:regular r:id="rId29" fontKey="{3547397D-CEC3-B89A-5FB5-020C9CB6E4DD}"/>
+      <p:bold r:id="rId30" fontKey="{0CB8D5B1-66EF-C706-0E19-6341EC3D8E46}"/>
+    </p:embeddedFont>
+    <p:embeddedFont>
+      <p:font typeface="JetBrains Mono"/>
+      <p:regular r:id="rId31" fontKey="{C6EB8399-2A56-D694-A331-105094B34A55}"/>
+    </p:embeddedFont>
+  </p:embeddedFontLst>
 </p:presentation>
 </file>
 
@@ -6197,7 +6213,7 @@
                 </a:solidFill>
                 <a:latin typeface="Montserrat"/>
               </a:rPr>
-              <a:t>Пик памяти 350 МиБ при бюджете 4 ГиБ</a:t>
+              <a:t>Пик памяти 350 МиБ — около 9% бюджета 4 ГиБ</a:t>
             </a:r>
           </a:p>
         </p:txBody>
@@ -6498,7 +6514,7 @@
                 </a:solidFill>
                 <a:latin typeface="Montserrat"/>
               </a:rPr>
-              <a:t>Условия замера: 95.66 МиБ, 250 000 пакетов, 1000 сессий, 4 vCPU / 16 ГиБ</a:t>
+              <a:t>Условия замера: 95.66 МиБ, 250 000 пакетов, 1000 сессий, 4 vCPU / 16 ГиБ. Бюджет памяти — 4 ГиБ</a:t>
             </a:r>
           </a:p>
         </p:txBody>
@@ -8197,6 +8213,206 @@
                       </p:childTnLst>
                     </p:cTn>
                   </p:par>
+                  <p:par>
+                    <p:cTn id="6" presetID="10" presetClass="entr" presetSubtype="0" fill="hold" grpId="0" nodeType="clickEffect">
+                      <p:stCondLst>
+                        <p:cond delay="0"/>
+                      </p:stCondLst>
+                      <p:childTnLst>
+                        <p:set>
+                          <p:cBhvr>
+                            <p:cTn id="7" dur="1" fill="hold">
+                              <p:stCondLst>
+                                <p:cond delay="0"/>
+                              </p:stCondLst>
+                            </p:cTn>
+                            <p:tgtEl>
+                              <p:spTgt spid="6"/>
+                            </p:tgtEl>
+                            <p:attrNameLst>
+                              <p:attrName>style.visibility</p:attrName>
+                            </p:attrNameLst>
+                          </p:cBhvr>
+                          <p:to>
+                            <p:strVal val="visible"/>
+                          </p:to>
+                        </p:set>
+                        <p:anim calcmode="lin" valueType="num">
+                          <p:cBhvr additive="base">
+                            <p:cTn id="8" dur="500" fill="hold"/>
+                            <p:tgtEl>
+                              <p:spTgt spid="6"/>
+                            </p:tgtEl>
+                            <p:attrNameLst>
+                              <p:attrName>style.opacity</p:attrName>
+                            </p:attrNameLst>
+                          </p:cBhvr>
+                          <p:tavLst>
+                            <p:tav tm="0">
+                              <p:val>
+                                <p:fltVal val="0"/>
+                              </p:val>
+                            </p:tav>
+                            <p:tav tm="100000">
+                              <p:val>
+                                <p:fltVal val="1"/>
+                              </p:val>
+                            </p:tav>
+                          </p:tavLst>
+                        </p:anim>
+                      </p:childTnLst>
+                    </p:cTn>
+                  </p:par>
+                  <p:par>
+                    <p:cTn id="9" presetID="10" presetClass="entr" presetSubtype="0" fill="hold" grpId="0" nodeType="clickEffect">
+                      <p:stCondLst>
+                        <p:cond delay="0"/>
+                      </p:stCondLst>
+                      <p:childTnLst>
+                        <p:set>
+                          <p:cBhvr>
+                            <p:cTn id="10" dur="1" fill="hold">
+                              <p:stCondLst>
+                                <p:cond delay="0"/>
+                              </p:stCondLst>
+                            </p:cTn>
+                            <p:tgtEl>
+                              <p:spTgt spid="7"/>
+                            </p:tgtEl>
+                            <p:attrNameLst>
+                              <p:attrName>style.visibility</p:attrName>
+                            </p:attrNameLst>
+                          </p:cBhvr>
+                          <p:to>
+                            <p:strVal val="visible"/>
+                          </p:to>
+                        </p:set>
+                        <p:anim calcmode="lin" valueType="num">
+                          <p:cBhvr additive="base">
+                            <p:cTn id="11" dur="500" fill="hold"/>
+                            <p:tgtEl>
+                              <p:spTgt spid="7"/>
+                            </p:tgtEl>
+                            <p:attrNameLst>
+                              <p:attrName>style.opacity</p:attrName>
+                            </p:attrNameLst>
+                          </p:cBhvr>
+                          <p:tavLst>
+                            <p:tav tm="0">
+                              <p:val>
+                                <p:fltVal val="0"/>
+                              </p:val>
+                            </p:tav>
+                            <p:tav tm="100000">
+                              <p:val>
+                                <p:fltVal val="1"/>
+                              </p:val>
+                            </p:tav>
+                          </p:tavLst>
+                        </p:anim>
+                      </p:childTnLst>
+                    </p:cTn>
+                  </p:par>
+                  <p:par>
+                    <p:cTn id="12" presetID="10" presetClass="entr" presetSubtype="0" fill="hold" grpId="0" nodeType="clickEffect">
+                      <p:stCondLst>
+                        <p:cond delay="0"/>
+                      </p:stCondLst>
+                      <p:childTnLst>
+                        <p:set>
+                          <p:cBhvr>
+                            <p:cTn id="13" dur="1" fill="hold">
+                              <p:stCondLst>
+                                <p:cond delay="0"/>
+                              </p:stCondLst>
+                            </p:cTn>
+                            <p:tgtEl>
+                              <p:spTgt spid="8"/>
+                            </p:tgtEl>
+                            <p:attrNameLst>
+                              <p:attrName>style.visibility</p:attrName>
+                            </p:attrNameLst>
+                          </p:cBhvr>
+                          <p:to>
+                            <p:strVal val="visible"/>
+                          </p:to>
+                        </p:set>
+                        <p:anim calcmode="lin" valueType="num">
+                          <p:cBhvr additive="base">
+                            <p:cTn id="14" dur="500" fill="hold"/>
+                            <p:tgtEl>
+                              <p:spTgt spid="8"/>
+                            </p:tgtEl>
+                            <p:attrNameLst>
+                              <p:attrName>style.opacity</p:attrName>
+                            </p:attrNameLst>
+                          </p:cBhvr>
+                          <p:tavLst>
+                            <p:tav tm="0">
+                              <p:val>
+                                <p:fltVal val="0"/>
+                              </p:val>
+                            </p:tav>
+                            <p:tav tm="100000">
+                              <p:val>
+                                <p:fltVal val="1"/>
+                              </p:val>
+                            </p:tav>
+                          </p:tavLst>
+                        </p:anim>
+                      </p:childTnLst>
+                    </p:cTn>
+                  </p:par>
+                  <p:par>
+                    <p:cTn id="15" presetID="10" presetClass="entr" presetSubtype="0" fill="hold" grpId="0" nodeType="clickEffect">
+                      <p:stCondLst>
+                        <p:cond delay="0"/>
+                      </p:stCondLst>
+                      <p:childTnLst>
+                        <p:set>
+                          <p:cBhvr>
+                            <p:cTn id="16" dur="1" fill="hold">
+                              <p:stCondLst>
+                                <p:cond delay="0"/>
+                              </p:stCondLst>
+                            </p:cTn>
+                            <p:tgtEl>
+                              <p:spTgt spid="9"/>
+                            </p:tgtEl>
+                            <p:attrNameLst>
+                              <p:attrName>style.visibility</p:attrName>
+                            </p:attrNameLst>
+                          </p:cBhvr>
+                          <p:to>
+                            <p:strVal val="visible"/>
+                          </p:to>
+                        </p:set>
+                        <p:anim calcmode="lin" valueType="num">
+                          <p:cBhvr additive="base">
+                            <p:cTn id="17" dur="500" fill="hold"/>
+                            <p:tgtEl>
+                              <p:spTgt spid="9"/>
+                            </p:tgtEl>
+                            <p:attrNameLst>
+                              <p:attrName>style.opacity</p:attrName>
+                            </p:attrNameLst>
+                          </p:cBhvr>
+                          <p:tavLst>
+                            <p:tav tm="0">
+                              <p:val>
+                                <p:fltVal val="0"/>
+                              </p:val>
+                            </p:tav>
+                            <p:tav tm="100000">
+                              <p:val>
+                                <p:fltVal val="1"/>
+                              </p:val>
+                            </p:tav>
+                          </p:tavLst>
+                        </p:anim>
+                      </p:childTnLst>
+                    </p:cTn>
+                  </p:par>
                 </p:childTnLst>
               </p:cTn>
             </p:seq>
@@ -9805,7 +10021,7 @@
                               </p:stCondLst>
                             </p:cTn>
                             <p:tgtEl>
-                              <p:spTgt spid="7"/>
+                              <p:spTgt spid="6"/>
                             </p:tgtEl>
                             <p:attrNameLst>
                               <p:attrName>style.visibility</p:attrName>
@@ -9819,7 +10035,7 @@
                           <p:cBhvr additive="base">
                             <p:cTn id="11" dur="500" fill="hold"/>
                             <p:tgtEl>
-                              <p:spTgt spid="7"/>
+                              <p:spTgt spid="6"/>
                             </p:tgtEl>
                             <p:attrNameLst>
                               <p:attrName>style.opacity</p:attrName>
@@ -9855,7 +10071,7 @@
                               </p:stCondLst>
                             </p:cTn>
                             <p:tgtEl>
-                              <p:spTgt spid="9"/>
+                              <p:spTgt spid="7"/>
                             </p:tgtEl>
                             <p:attrNameLst>
                               <p:attrName>style.visibility</p:attrName>
@@ -9869,7 +10085,7 @@
                           <p:cBhvr additive="base">
                             <p:cTn id="14" dur="500" fill="hold"/>
                             <p:tgtEl>
-                              <p:spTgt spid="9"/>
+                              <p:spTgt spid="7"/>
                             </p:tgtEl>
                             <p:attrNameLst>
                               <p:attrName>style.opacity</p:attrName>
@@ -9905,7 +10121,7 @@
                               </p:stCondLst>
                             </p:cTn>
                             <p:tgtEl>
-                              <p:spTgt spid="11"/>
+                              <p:spTgt spid="8"/>
                             </p:tgtEl>
                             <p:attrNameLst>
                               <p:attrName>style.visibility</p:attrName>
@@ -9919,7 +10135,207 @@
                           <p:cBhvr additive="base">
                             <p:cTn id="17" dur="500" fill="hold"/>
                             <p:tgtEl>
+                              <p:spTgt spid="8"/>
+                            </p:tgtEl>
+                            <p:attrNameLst>
+                              <p:attrName>style.opacity</p:attrName>
+                            </p:attrNameLst>
+                          </p:cBhvr>
+                          <p:tavLst>
+                            <p:tav tm="0">
+                              <p:val>
+                                <p:fltVal val="0"/>
+                              </p:val>
+                            </p:tav>
+                            <p:tav tm="100000">
+                              <p:val>
+                                <p:fltVal val="1"/>
+                              </p:val>
+                            </p:tav>
+                          </p:tavLst>
+                        </p:anim>
+                      </p:childTnLst>
+                    </p:cTn>
+                  </p:par>
+                  <p:par>
+                    <p:cTn id="18" presetID="10" presetClass="entr" presetSubtype="0" fill="hold" grpId="0" nodeType="clickEffect">
+                      <p:stCondLst>
+                        <p:cond delay="0"/>
+                      </p:stCondLst>
+                      <p:childTnLst>
+                        <p:set>
+                          <p:cBhvr>
+                            <p:cTn id="19" dur="1" fill="hold">
+                              <p:stCondLst>
+                                <p:cond delay="0"/>
+                              </p:stCondLst>
+                            </p:cTn>
+                            <p:tgtEl>
+                              <p:spTgt spid="9"/>
+                            </p:tgtEl>
+                            <p:attrNameLst>
+                              <p:attrName>style.visibility</p:attrName>
+                            </p:attrNameLst>
+                          </p:cBhvr>
+                          <p:to>
+                            <p:strVal val="visible"/>
+                          </p:to>
+                        </p:set>
+                        <p:anim calcmode="lin" valueType="num">
+                          <p:cBhvr additive="base">
+                            <p:cTn id="20" dur="500" fill="hold"/>
+                            <p:tgtEl>
+                              <p:spTgt spid="9"/>
+                            </p:tgtEl>
+                            <p:attrNameLst>
+                              <p:attrName>style.opacity</p:attrName>
+                            </p:attrNameLst>
+                          </p:cBhvr>
+                          <p:tavLst>
+                            <p:tav tm="0">
+                              <p:val>
+                                <p:fltVal val="0"/>
+                              </p:val>
+                            </p:tav>
+                            <p:tav tm="100000">
+                              <p:val>
+                                <p:fltVal val="1"/>
+                              </p:val>
+                            </p:tav>
+                          </p:tavLst>
+                        </p:anim>
+                      </p:childTnLst>
+                    </p:cTn>
+                  </p:par>
+                  <p:par>
+                    <p:cTn id="21" presetID="10" presetClass="entr" presetSubtype="0" fill="hold" grpId="0" nodeType="clickEffect">
+                      <p:stCondLst>
+                        <p:cond delay="0"/>
+                      </p:stCondLst>
+                      <p:childTnLst>
+                        <p:set>
+                          <p:cBhvr>
+                            <p:cTn id="22" dur="1" fill="hold">
+                              <p:stCondLst>
+                                <p:cond delay="0"/>
+                              </p:stCondLst>
+                            </p:cTn>
+                            <p:tgtEl>
+                              <p:spTgt spid="10"/>
+                            </p:tgtEl>
+                            <p:attrNameLst>
+                              <p:attrName>style.visibility</p:attrName>
+                            </p:attrNameLst>
+                          </p:cBhvr>
+                          <p:to>
+                            <p:strVal val="visible"/>
+                          </p:to>
+                        </p:set>
+                        <p:anim calcmode="lin" valueType="num">
+                          <p:cBhvr additive="base">
+                            <p:cTn id="23" dur="500" fill="hold"/>
+                            <p:tgtEl>
+                              <p:spTgt spid="10"/>
+                            </p:tgtEl>
+                            <p:attrNameLst>
+                              <p:attrName>style.opacity</p:attrName>
+                            </p:attrNameLst>
+                          </p:cBhvr>
+                          <p:tavLst>
+                            <p:tav tm="0">
+                              <p:val>
+                                <p:fltVal val="0"/>
+                              </p:val>
+                            </p:tav>
+                            <p:tav tm="100000">
+                              <p:val>
+                                <p:fltVal val="1"/>
+                              </p:val>
+                            </p:tav>
+                          </p:tavLst>
+                        </p:anim>
+                      </p:childTnLst>
+                    </p:cTn>
+                  </p:par>
+                  <p:par>
+                    <p:cTn id="24" presetID="10" presetClass="entr" presetSubtype="0" fill="hold" grpId="0" nodeType="clickEffect">
+                      <p:stCondLst>
+                        <p:cond delay="0"/>
+                      </p:stCondLst>
+                      <p:childTnLst>
+                        <p:set>
+                          <p:cBhvr>
+                            <p:cTn id="25" dur="1" fill="hold">
+                              <p:stCondLst>
+                                <p:cond delay="0"/>
+                              </p:stCondLst>
+                            </p:cTn>
+                            <p:tgtEl>
                               <p:spTgt spid="11"/>
+                            </p:tgtEl>
+                            <p:attrNameLst>
+                              <p:attrName>style.visibility</p:attrName>
+                            </p:attrNameLst>
+                          </p:cBhvr>
+                          <p:to>
+                            <p:strVal val="visible"/>
+                          </p:to>
+                        </p:set>
+                        <p:anim calcmode="lin" valueType="num">
+                          <p:cBhvr additive="base">
+                            <p:cTn id="26" dur="500" fill="hold"/>
+                            <p:tgtEl>
+                              <p:spTgt spid="11"/>
+                            </p:tgtEl>
+                            <p:attrNameLst>
+                              <p:attrName>style.opacity</p:attrName>
+                            </p:attrNameLst>
+                          </p:cBhvr>
+                          <p:tavLst>
+                            <p:tav tm="0">
+                              <p:val>
+                                <p:fltVal val="0"/>
+                              </p:val>
+                            </p:tav>
+                            <p:tav tm="100000">
+                              <p:val>
+                                <p:fltVal val="1"/>
+                              </p:val>
+                            </p:tav>
+                          </p:tavLst>
+                        </p:anim>
+                      </p:childTnLst>
+                    </p:cTn>
+                  </p:par>
+                  <p:par>
+                    <p:cTn id="27" presetID="10" presetClass="entr" presetSubtype="0" fill="hold" grpId="0" nodeType="clickEffect">
+                      <p:stCondLst>
+                        <p:cond delay="0"/>
+                      </p:stCondLst>
+                      <p:childTnLst>
+                        <p:set>
+                          <p:cBhvr>
+                            <p:cTn id="28" dur="1" fill="hold">
+                              <p:stCondLst>
+                                <p:cond delay="0"/>
+                              </p:stCondLst>
+                            </p:cTn>
+                            <p:tgtEl>
+                              <p:spTgt spid="12"/>
+                            </p:tgtEl>
+                            <p:attrNameLst>
+                              <p:attrName>style.visibility</p:attrName>
+                            </p:attrNameLst>
+                          </p:cBhvr>
+                          <p:to>
+                            <p:strVal val="visible"/>
+                          </p:to>
+                        </p:set>
+                        <p:anim calcmode="lin" valueType="num">
+                          <p:cBhvr additive="base">
+                            <p:cTn id="29" dur="500" fill="hold"/>
+                            <p:tgtEl>
+                              <p:spTgt spid="12"/>
                             </p:tgtEl>
                             <p:attrNameLst>
                               <p:attrName>style.opacity</p:attrName>
@@ -10105,7 +10521,7 @@
         <p:spPr>
           <a:xfrm>
             <a:off x="822960" y="1691640"/>
-            <a:ext cx="5044287" cy="2377440"/>
+            <a:ext cx="5044287" cy="2468880"/>
           </a:xfrm>
           <a:prstGeom prst="rect">
             <a:avLst/>
@@ -10172,7 +10588,7 @@
         </p:nvSpPr>
         <p:spPr>
           <a:xfrm>
-            <a:off x="2971800" y="2103120"/>
+            <a:off x="2971800" y="2148840"/>
             <a:ext cx="1752447" cy="548640"/>
           </a:xfrm>
           <a:prstGeom prst="rect">
@@ -10187,7 +10603,7 @@
           <a:lstStyle/>
           <a:p>
             <a:r>
-              <a:rPr sz="2400" b="1">
+              <a:rPr sz="2100" b="1">
                 <a:solidFill>
                   <a:srgbClr val="F4F1EC"/>
                 </a:solidFill>
@@ -10206,7 +10622,7 @@
         </p:nvSpPr>
         <p:spPr>
           <a:xfrm>
-            <a:off x="2971800" y="2651760"/>
+            <a:off x="2971800" y="2697480"/>
             <a:ext cx="1752447" cy="457200"/>
           </a:xfrm>
           <a:prstGeom prst="rect">
@@ -10240,7 +10656,7 @@
         </p:nvSpPr>
         <p:spPr>
           <a:xfrm>
-            <a:off x="2971800" y="3108960"/>
+            <a:off x="2971800" y="3154680"/>
             <a:ext cx="1752447" cy="365760"/>
           </a:xfrm>
           <a:prstGeom prst="rect">
@@ -10282,8 +10698,8 @@
         </p:blipFill>
         <p:spPr>
           <a:xfrm>
-            <a:off x="4495647" y="2194560"/>
-            <a:ext cx="1097280" cy="1097280"/>
+            <a:off x="4815687" y="2148840"/>
+            <a:ext cx="758952" cy="758952"/>
           </a:xfrm>
           <a:prstGeom prst="rect">
             <a:avLst/>
@@ -10299,7 +10715,7 @@
         <p:spPr>
           <a:xfrm>
             <a:off x="6324447" y="1691640"/>
-            <a:ext cx="5044287" cy="2377440"/>
+            <a:ext cx="5044287" cy="2468880"/>
           </a:xfrm>
           <a:prstGeom prst="rect">
             <a:avLst/>
@@ -10366,7 +10782,7 @@
         </p:nvSpPr>
         <p:spPr>
           <a:xfrm>
-            <a:off x="8473287" y="2103120"/>
+            <a:off x="8473287" y="2148840"/>
             <a:ext cx="1752447" cy="548640"/>
           </a:xfrm>
           <a:prstGeom prst="rect">
@@ -10381,7 +10797,7 @@
           <a:lstStyle/>
           <a:p>
             <a:r>
-              <a:rPr sz="2400" b="1">
+              <a:rPr sz="2100" b="1">
                 <a:solidFill>
                   <a:srgbClr val="F4F1EC"/>
                 </a:solidFill>
@@ -10400,7 +10816,7 @@
         </p:nvSpPr>
         <p:spPr>
           <a:xfrm>
-            <a:off x="8473287" y="2651760"/>
+            <a:off x="8473287" y="2697480"/>
             <a:ext cx="1752447" cy="457200"/>
           </a:xfrm>
           <a:prstGeom prst="rect">
@@ -10434,7 +10850,7 @@
         </p:nvSpPr>
         <p:spPr>
           <a:xfrm>
-            <a:off x="8473287" y="3108960"/>
+            <a:off x="8473287" y="3154680"/>
             <a:ext cx="1752447" cy="365760"/>
           </a:xfrm>
           <a:prstGeom prst="rect">
@@ -10476,8 +10892,8 @@
         </p:blipFill>
         <p:spPr>
           <a:xfrm>
-            <a:off x="9997135" y="2194560"/>
-            <a:ext cx="1097280" cy="1097280"/>
+            <a:off x="10317175" y="2148840"/>
+            <a:ext cx="758952" cy="758952"/>
           </a:xfrm>
           <a:prstGeom prst="rect">
             <a:avLst/>
@@ -15240,7 +15656,7 @@
                 </a:solidFill>
                 <a:latin typeface="Montserrat"/>
               </a:rPr>
-              <a:t>4 НЕЗАВИСИМЫХ СЕССИИ + ЖУРНАЛ ДЕЙСТВИЙ УСТРОЙСТВА</a:t>
+              <a:t>4 НЕЗАВИСИМЫЕ СЕССИИ В КОРПУСЕ + ЖУРНАЛ ДЕЙСТВИЙ УСТРОЙСТВА</a:t>
             </a:r>
           </a:p>
         </p:txBody>
@@ -15532,7 +15948,7 @@
                 </a:solidFill>
                 <a:latin typeface="Montserrat"/>
               </a:rPr>
-              <a:t>Значение 2 повторяется в 4 независимых сессиях и связано с действием «изменить настройку» в журнале</a:t>
+              <a:t>Значение 2 повторяется в 4 независимых сессиях корпуса и связано с действием «изменить настройку» в журнале</a:t>
             </a:r>
           </a:p>
         </p:txBody>
@@ -15909,7 +16325,7 @@
     </a:clrScheme>
     <a:fontScheme name="Office">
       <a:majorFont>
-        <a:latin typeface="Calibri"/>
+        <a:latin typeface="Montserrat"/>
         <a:ea typeface=""/>
         <a:cs typeface=""/>
         <a:font script="Jpan" typeface="ＭＳ Ｐゴシック"/>
@@ -15944,7 +16360,7 @@
         <a:font script="Geor" typeface="Sylfaen"/>
       </a:majorFont>
       <a:minorFont>
-        <a:latin typeface="Calibri"/>
+        <a:latin typeface="Montserrat"/>
         <a:ea typeface=""/>
         <a:cs typeface=""/>
         <a:font script="Jpan" typeface="ＭＳ Ｐゴシック"/>

</xml_diff>

<commit_message>
feat(presentation): rebrand for Мадригал and fix slide composition
The deck carried a third-party «Волга» wordmark; the case owner is
«Мадригал». Replace it with a generated neutral mark and tighten the
layout so no slide reaches the footer band.

- add presentation/make_brand.py (wordmark + monogram), drop fstek.png
- cover/closing carry the new «Мадригал» mark; PPTX white plate removed
- style.css: rebranded gradient tokens, line-height 1.58, soft card
  shadow, faint «М» watermark in the empty corner
- slide 13 wrapped in .limits-page; trims on slides 6/7/12
- check_layout.py: 0 problems on both PDFs; 839 tests pass
</commit_message>
<xml_diff>
--- a/presentation/slides.pptx
+++ b/presentation/slides.pptx
@@ -3939,53 +3939,9 @@
           </a:p>
         </p:txBody>
       </p:sp>
-      <p:sp>
-        <p:nvSpPr>
-          <p:cNvPr id="7" name="Rectangle 6"/>
-          <p:cNvSpPr/>
-          <p:nvPr/>
-        </p:nvSpPr>
-        <p:spPr>
-          <a:xfrm>
-            <a:off x="8826703" y="1280160"/>
-            <a:ext cx="2706624" cy="804672"/>
-          </a:xfrm>
-          <a:prstGeom prst="rect">
-            <a:avLst/>
-          </a:prstGeom>
-          <a:solidFill>
-            <a:srgbClr val="FFFFFF"/>
-          </a:solidFill>
-          <a:ln>
-            <a:noFill/>
-          </a:ln>
-          <a:effectLst/>
-        </p:spPr>
-        <p:style>
-          <a:lnRef idx="1">
-            <a:schemeClr val="accent1"/>
-          </a:lnRef>
-          <a:fillRef idx="3">
-            <a:schemeClr val="accent1"/>
-          </a:fillRef>
-          <a:effectRef idx="2">
-            <a:schemeClr val="accent1"/>
-          </a:effectRef>
-          <a:fontRef idx="minor">
-            <a:schemeClr val="lt1"/>
-          </a:fontRef>
-        </p:style>
-        <p:txBody>
-          <a:bodyPr rtlCol="0" anchor="ctr"/>
-          <a:lstStyle/>
-          <a:p>
-            <a:pPr algn="ctr"/>
-          </a:p>
-        </p:txBody>
-      </p:sp>
       <p:pic>
         <p:nvPicPr>
-          <p:cNvPr id="8" name="Picture 7" descr="madrigal-logo.png"/>
+          <p:cNvPr id="7" name="Picture 6" descr="madrigal-logo.png"/>
           <p:cNvPicPr>
             <a:picLocks noChangeAspect="1"/>
           </p:cNvPicPr>
@@ -3999,14 +3955,49 @@
         </p:blipFill>
         <p:spPr>
           <a:xfrm>
-            <a:off x="8991295" y="1426464"/>
-            <a:ext cx="2377440" cy="497677"/>
+            <a:off x="8991295" y="1298448"/>
+            <a:ext cx="2377440" cy="576072"/>
           </a:xfrm>
           <a:prstGeom prst="rect">
             <a:avLst/>
           </a:prstGeom>
         </p:spPr>
       </p:pic>
+      <p:sp>
+        <p:nvSpPr>
+          <p:cNvPr id="8" name="TextBox 7"/>
+          <p:cNvSpPr txBox="1"/>
+          <p:nvPr/>
+        </p:nvSpPr>
+        <p:spPr>
+          <a:xfrm>
+            <a:off x="8991295" y="1975104"/>
+            <a:ext cx="2377440" cy="274320"/>
+          </a:xfrm>
+          <a:prstGeom prst="rect">
+            <a:avLst/>
+          </a:prstGeom>
+          <a:noFill/>
+        </p:spPr>
+        <p:txBody>
+          <a:bodyPr wrap="square" anchor="t">
+            <a:spAutoFit/>
+          </a:bodyPr>
+          <a:lstStyle/>
+          <a:p>
+            <a:pPr algn="r"/>
+            <a:r>
+              <a:rPr sz="1000" b="0">
+                <a:solidFill>
+                  <a:srgbClr val="A8A29E"/>
+                </a:solidFill>
+                <a:latin typeface="JetBrains Mono"/>
+              </a:rPr>
+              <a:t>кейс #02 · UMIRHack 2026</a:t>
+            </a:r>
+          </a:p>
+        </p:txBody>
+      </p:sp>
       <p:sp>
         <p:nvSpPr>
           <p:cNvPr id="9" name="TextBox 8"/>
@@ -7085,53 +7076,9 @@
           </a:p>
         </p:txBody>
       </p:sp>
-      <p:sp>
-        <p:nvSpPr>
-          <p:cNvPr id="14" name="Rectangle 13"/>
-          <p:cNvSpPr/>
-          <p:nvPr/>
-        </p:nvSpPr>
-        <p:spPr>
-          <a:xfrm>
-            <a:off x="4727448" y="5532120"/>
-            <a:ext cx="2743200" cy="658368"/>
-          </a:xfrm>
-          <a:prstGeom prst="rect">
-            <a:avLst/>
-          </a:prstGeom>
-          <a:solidFill>
-            <a:srgbClr val="FFFFFF"/>
-          </a:solidFill>
-          <a:ln>
-            <a:noFill/>
-          </a:ln>
-          <a:effectLst/>
-        </p:spPr>
-        <p:style>
-          <a:lnRef idx="1">
-            <a:schemeClr val="accent1"/>
-          </a:lnRef>
-          <a:fillRef idx="3">
-            <a:schemeClr val="accent1"/>
-          </a:fillRef>
-          <a:effectRef idx="2">
-            <a:schemeClr val="accent1"/>
-          </a:effectRef>
-          <a:fontRef idx="minor">
-            <a:schemeClr val="lt1"/>
-          </a:fontRef>
-        </p:style>
-        <p:txBody>
-          <a:bodyPr rtlCol="0" anchor="ctr"/>
-          <a:lstStyle/>
-          <a:p>
-            <a:pPr algn="ctr"/>
-          </a:p>
-        </p:txBody>
-      </p:sp>
       <p:pic>
         <p:nvPicPr>
-          <p:cNvPr id="15" name="Picture 14" descr="madrigal-logo.png"/>
+          <p:cNvPr id="14" name="Picture 13" descr="madrigal-logo.png"/>
           <p:cNvPicPr>
             <a:picLocks noChangeAspect="1"/>
           </p:cNvPicPr>
@@ -7146,7 +7093,7 @@
         <p:spPr>
           <a:xfrm>
             <a:off x="4910328" y="5660136"/>
-            <a:ext cx="2377440" cy="497677"/>
+            <a:ext cx="2377440" cy="576072"/>
           </a:xfrm>
           <a:prstGeom prst="rect">
             <a:avLst/>
@@ -7155,7 +7102,7 @@
       </p:pic>
       <p:sp>
         <p:nvSpPr>
-          <p:cNvPr id="16" name="TextBox 15"/>
+          <p:cNvPr id="15" name="TextBox 14"/>
           <p:cNvSpPr txBox="1"/>
           <p:nvPr/>
         </p:nvSpPr>

</xml_diff>

<commit_message>
feat(presentation): add large-number accents and bump deck to v1.1.0
Slide 9 leads with the correction result (80 -> 0 counterexamples) and
slide 11 with the corpus figures (12 s, 350 MiB, 250k packets), matching
the redesign while keeping the brand fonts and burgundy accent. Bars and
accents are re-fit so nothing reaches the footer band on either deck.
</commit_message>
<xml_diff>
--- a/presentation/slides.pptx
+++ b/presentation/slides.pptx
@@ -5296,7 +5296,7 @@
         </p:nvSpPr>
         <p:spPr>
           <a:xfrm>
-            <a:off x="822960" y="4206240"/>
+            <a:off x="822960" y="3931920"/>
             <a:ext cx="5120640" cy="1097280"/>
           </a:xfrm>
           <a:prstGeom prst="rect">
@@ -5322,43 +5322,9 @@
           </a:p>
         </p:txBody>
       </p:sp>
-      <p:sp>
-        <p:nvSpPr>
-          <p:cNvPr id="7" name="TextBox 6"/>
-          <p:cNvSpPr txBox="1"/>
-          <p:nvPr/>
-        </p:nvSpPr>
-        <p:spPr>
-          <a:xfrm>
-            <a:off x="822960" y="4800600"/>
-            <a:ext cx="5120640" cy="548640"/>
-          </a:xfrm>
-          <a:prstGeom prst="rect">
-            <a:avLst/>
-          </a:prstGeom>
-          <a:noFill/>
-        </p:spPr>
-        <p:txBody>
-          <a:bodyPr wrap="square" anchor="t">
-            <a:spAutoFit/>
-          </a:bodyPr>
-          <a:lstStyle/>
-          <a:p>
-            <a:r>
-              <a:rPr sz="1500" b="0">
-                <a:solidFill>
-                  <a:srgbClr val="A8A29E"/>
-                </a:solidFill>
-                <a:latin typeface="Montserrat"/>
-              </a:rPr>
-              <a:t>12 с на 95 МиБ — пик памяти 350 МиБ, 9% бюджета 4 ГиБ</a:t>
-            </a:r>
-          </a:p>
-        </p:txBody>
-      </p:sp>
       <p:pic>
         <p:nvPicPr>
-          <p:cNvPr id="8" name="Picture 7" descr="coverage_donut.png"/>
+          <p:cNvPr id="7" name="Picture 6" descr="coverage_donut.png"/>
           <p:cNvPicPr>
             <a:picLocks noChangeAspect="1"/>
           </p:cNvPicPr>
@@ -5372,8 +5338,8 @@
         </p:blipFill>
         <p:spPr>
           <a:xfrm>
-            <a:off x="6035040" y="2011680"/>
-            <a:ext cx="4772264" cy="3657600"/>
+            <a:off x="6035040" y="1737360"/>
+            <a:ext cx="3579198" cy="2743200"/>
           </a:xfrm>
           <a:prstGeom prst="rect">
             <a:avLst/>
@@ -5382,60 +5348,48 @@
       </p:pic>
       <p:sp>
         <p:nvSpPr>
-          <p:cNvPr id="9" name="Rounded Rectangle 8"/>
-          <p:cNvSpPr/>
-          <p:nvPr/>
-        </p:nvSpPr>
-        <p:spPr>
-          <a:xfrm>
-            <a:off x="822960" y="4937760"/>
-            <a:ext cx="1444752" cy="365760"/>
-          </a:xfrm>
-          <a:prstGeom prst="roundRect">
-            <a:avLst/>
-          </a:prstGeom>
-          <a:solidFill>
-            <a:srgbClr val="26282B"/>
-          </a:solidFill>
-          <a:ln w="12700">
-            <a:solidFill>
-              <a:srgbClr val="26282B"/>
-            </a:solidFill>
-          </a:ln>
-          <a:effectLst/>
-        </p:spPr>
-        <p:style>
-          <a:lnRef idx="1">
-            <a:schemeClr val="accent1"/>
-          </a:lnRef>
-          <a:fillRef idx="3">
-            <a:schemeClr val="accent1"/>
-          </a:fillRef>
-          <a:effectRef idx="2">
-            <a:schemeClr val="accent1"/>
-          </a:effectRef>
-          <a:fontRef idx="minor">
-            <a:schemeClr val="lt1"/>
-          </a:fontRef>
-        </p:style>
-        <p:txBody>
-          <a:bodyPr rtlCol="0" anchor="ctr"/>
-          <a:lstStyle/>
-          <a:p>
-            <a:pPr algn="ctr"/>
-          </a:p>
-        </p:txBody>
-      </p:sp>
-      <p:sp>
-        <p:nvSpPr>
-          <p:cNvPr id="10" name="TextBox 9"/>
+          <p:cNvPr id="8" name="TextBox 7"/>
           <p:cNvSpPr txBox="1"/>
           <p:nvPr/>
         </p:nvSpPr>
         <p:spPr>
           <a:xfrm>
-            <a:off x="822960" y="4983480"/>
-            <a:ext cx="1444752" cy="292608"/>
+            <a:off x="822960" y="4617720"/>
+            <a:ext cx="2377440" cy="1097280"/>
+          </a:xfrm>
+          <a:prstGeom prst="rect">
+            <a:avLst/>
+          </a:prstGeom>
+          <a:noFill/>
+        </p:spPr>
+        <p:txBody>
+          <a:bodyPr wrap="square" anchor="b">
+            <a:spAutoFit/>
+          </a:bodyPr>
+          <a:lstStyle/>
+          <a:p>
+            <a:r>
+              <a:rPr sz="4400" b="1">
+                <a:solidFill>
+                  <a:srgbClr val="D0603A"/>
+                </a:solidFill>
+                <a:latin typeface="Tektur"/>
+              </a:rPr>
+              <a:t>12 с</a:t>
+            </a:r>
+          </a:p>
+        </p:txBody>
+      </p:sp>
+      <p:sp>
+        <p:nvSpPr>
+          <p:cNvPr id="9" name="TextBox 8"/>
+          <p:cNvSpPr txBox="1"/>
+          <p:nvPr/>
+        </p:nvSpPr>
+        <p:spPr>
+          <a:xfrm>
+            <a:off x="822960" y="5669280"/>
+            <a:ext cx="2377440" cy="365760"/>
           </a:xfrm>
           <a:prstGeom prst="rect">
             <a:avLst/>
@@ -5448,75 +5402,62 @@
           </a:bodyPr>
           <a:lstStyle/>
           <a:p>
-            <a:pPr algn="ctr"/>
-            <a:r>
-              <a:rPr sz="1400" b="0">
-                <a:solidFill>
-                  <a:srgbClr val="F4F1EC"/>
+            <a:r>
+              <a:rPr sz="1500" b="0">
+                <a:solidFill>
+                  <a:srgbClr val="A8A29E"/>
                 </a:solidFill>
                 <a:latin typeface="Montserrat"/>
               </a:rPr>
-              <a:t>12 с общее время</a:t>
-            </a:r>
-          </a:p>
-        </p:txBody>
-      </p:sp>
-      <p:sp>
-        <p:nvSpPr>
-          <p:cNvPr id="11" name="Rounded Rectangle 10"/>
-          <p:cNvSpPr/>
-          <p:nvPr/>
-        </p:nvSpPr>
-        <p:spPr>
-          <a:xfrm>
-            <a:off x="2496312" y="4937760"/>
-            <a:ext cx="1600200" cy="365760"/>
-          </a:xfrm>
-          <a:prstGeom prst="roundRect">
-            <a:avLst/>
-          </a:prstGeom>
-          <a:solidFill>
-            <a:srgbClr val="26282B"/>
-          </a:solidFill>
-          <a:ln w="12700">
-            <a:solidFill>
-              <a:srgbClr val="26282B"/>
-            </a:solidFill>
-          </a:ln>
-          <a:effectLst/>
-        </p:spPr>
-        <p:style>
-          <a:lnRef idx="1">
-            <a:schemeClr val="accent1"/>
-          </a:lnRef>
-          <a:fillRef idx="3">
-            <a:schemeClr val="accent1"/>
-          </a:fillRef>
-          <a:effectRef idx="2">
-            <a:schemeClr val="accent1"/>
-          </a:effectRef>
-          <a:fontRef idx="minor">
-            <a:schemeClr val="lt1"/>
-          </a:fontRef>
-        </p:style>
-        <p:txBody>
-          <a:bodyPr rtlCol="0" anchor="ctr"/>
-          <a:lstStyle/>
-          <a:p>
-            <a:pPr algn="ctr"/>
-          </a:p>
-        </p:txBody>
-      </p:sp>
-      <p:sp>
-        <p:nvSpPr>
-          <p:cNvPr id="12" name="TextBox 11"/>
+              <a:t>общее время на 95 МиБ</a:t>
+            </a:r>
+          </a:p>
+        </p:txBody>
+      </p:sp>
+      <p:sp>
+        <p:nvSpPr>
+          <p:cNvPr id="10" name="TextBox 9"/>
           <p:cNvSpPr txBox="1"/>
           <p:nvPr/>
         </p:nvSpPr>
         <p:spPr>
           <a:xfrm>
-            <a:off x="2496312" y="4983480"/>
-            <a:ext cx="1600200" cy="292608"/>
+            <a:off x="3291840" y="4617720"/>
+            <a:ext cx="2377440" cy="1097280"/>
+          </a:xfrm>
+          <a:prstGeom prst="rect">
+            <a:avLst/>
+          </a:prstGeom>
+          <a:noFill/>
+        </p:spPr>
+        <p:txBody>
+          <a:bodyPr wrap="square" anchor="b">
+            <a:spAutoFit/>
+          </a:bodyPr>
+          <a:lstStyle/>
+          <a:p>
+            <a:r>
+              <a:rPr sz="4400" b="1">
+                <a:solidFill>
+                  <a:srgbClr val="D0603A"/>
+                </a:solidFill>
+                <a:latin typeface="Tektur"/>
+              </a:rPr>
+              <a:t>350 МиБ</a:t>
+            </a:r>
+          </a:p>
+        </p:txBody>
+      </p:sp>
+      <p:sp>
+        <p:nvSpPr>
+          <p:cNvPr id="11" name="TextBox 10"/>
+          <p:cNvSpPr txBox="1"/>
+          <p:nvPr/>
+        </p:nvSpPr>
+        <p:spPr>
+          <a:xfrm>
+            <a:off x="3291840" y="5669280"/>
+            <a:ext cx="2377440" cy="365760"/>
           </a:xfrm>
           <a:prstGeom prst="rect">
             <a:avLst/>
@@ -5529,75 +5470,62 @@
           </a:bodyPr>
           <a:lstStyle/>
           <a:p>
-            <a:pPr algn="ctr"/>
-            <a:r>
-              <a:rPr sz="1400" b="0">
-                <a:solidFill>
-                  <a:srgbClr val="F4F1EC"/>
+            <a:r>
+              <a:rPr sz="1500" b="0">
+                <a:solidFill>
+                  <a:srgbClr val="A8A29E"/>
                 </a:solidFill>
                 <a:latin typeface="Montserrat"/>
               </a:rPr>
-              <a:t>350 МиБ пик памяти</a:t>
-            </a:r>
-          </a:p>
-        </p:txBody>
-      </p:sp>
-      <p:sp>
-        <p:nvSpPr>
-          <p:cNvPr id="13" name="Rounded Rectangle 12"/>
-          <p:cNvSpPr/>
-          <p:nvPr/>
-        </p:nvSpPr>
-        <p:spPr>
-          <a:xfrm>
-            <a:off x="4325112" y="4937760"/>
-            <a:ext cx="1133856" cy="365760"/>
-          </a:xfrm>
-          <a:prstGeom prst="roundRect">
-            <a:avLst/>
-          </a:prstGeom>
-          <a:solidFill>
-            <a:srgbClr val="26282B"/>
-          </a:solidFill>
-          <a:ln w="12700">
-            <a:solidFill>
-              <a:srgbClr val="26282B"/>
-            </a:solidFill>
-          </a:ln>
-          <a:effectLst/>
-        </p:spPr>
-        <p:style>
-          <a:lnRef idx="1">
-            <a:schemeClr val="accent1"/>
-          </a:lnRef>
-          <a:fillRef idx="3">
-            <a:schemeClr val="accent1"/>
-          </a:fillRef>
-          <a:effectRef idx="2">
-            <a:schemeClr val="accent1"/>
-          </a:effectRef>
-          <a:fontRef idx="minor">
-            <a:schemeClr val="lt1"/>
-          </a:fontRef>
-        </p:style>
-        <p:txBody>
-          <a:bodyPr rtlCol="0" anchor="ctr"/>
-          <a:lstStyle/>
-          <a:p>
-            <a:pPr algn="ctr"/>
-          </a:p>
-        </p:txBody>
-      </p:sp>
-      <p:sp>
-        <p:nvSpPr>
-          <p:cNvPr id="14" name="TextBox 13"/>
+              <a:t>пик памяти · 9% бюджета</a:t>
+            </a:r>
+          </a:p>
+        </p:txBody>
+      </p:sp>
+      <p:sp>
+        <p:nvSpPr>
+          <p:cNvPr id="12" name="TextBox 11"/>
           <p:cNvSpPr txBox="1"/>
           <p:nvPr/>
         </p:nvSpPr>
         <p:spPr>
           <a:xfrm>
-            <a:off x="4325112" y="4983480"/>
-            <a:ext cx="1133856" cy="292608"/>
+            <a:off x="5760720" y="4617720"/>
+            <a:ext cx="2377440" cy="1097280"/>
+          </a:xfrm>
+          <a:prstGeom prst="rect">
+            <a:avLst/>
+          </a:prstGeom>
+          <a:noFill/>
+        </p:spPr>
+        <p:txBody>
+          <a:bodyPr wrap="square" anchor="b">
+            <a:spAutoFit/>
+          </a:bodyPr>
+          <a:lstStyle/>
+          <a:p>
+            <a:r>
+              <a:rPr sz="4400" b="1">
+                <a:solidFill>
+                  <a:srgbClr val="D0603A"/>
+                </a:solidFill>
+                <a:latin typeface="Tektur"/>
+              </a:rPr>
+              <a:t>250k</a:t>
+            </a:r>
+          </a:p>
+        </p:txBody>
+      </p:sp>
+      <p:sp>
+        <p:nvSpPr>
+          <p:cNvPr id="13" name="TextBox 12"/>
+          <p:cNvSpPr txBox="1"/>
+          <p:nvPr/>
+        </p:nvSpPr>
+        <p:spPr>
+          <a:xfrm>
+            <a:off x="5760720" y="5669280"/>
+            <a:ext cx="2377440" cy="365760"/>
           </a:xfrm>
           <a:prstGeom prst="rect">
             <a:avLst/>
@@ -5610,22 +5538,21 @@
           </a:bodyPr>
           <a:lstStyle/>
           <a:p>
-            <a:pPr algn="ctr"/>
-            <a:r>
-              <a:rPr sz="1400" b="0">
-                <a:solidFill>
-                  <a:srgbClr val="F4F1EC"/>
+            <a:r>
+              <a:rPr sz="1500" b="0">
+                <a:solidFill>
+                  <a:srgbClr val="A8A29E"/>
                 </a:solidFill>
                 <a:latin typeface="Montserrat"/>
               </a:rPr>
-              <a:t>250k пакетов</a:t>
-            </a:r>
-          </a:p>
-        </p:txBody>
-      </p:sp>
-      <p:sp>
-        <p:nvSpPr>
-          <p:cNvPr id="15" name="TextBox 14"/>
+              <a:t>пакетов разобрано</a:t>
+            </a:r>
+          </a:p>
+        </p:txBody>
+      </p:sp>
+      <p:sp>
+        <p:nvSpPr>
+          <p:cNvPr id="14" name="TextBox 13"/>
           <p:cNvSpPr txBox="1"/>
           <p:nvPr/>
         </p:nvSpPr>
@@ -5659,7 +5586,7 @@
       </p:sp>
       <p:sp>
         <p:nvSpPr>
-          <p:cNvPr id="16" name="TextBox 15"/>
+          <p:cNvPr id="15" name="TextBox 14"/>
           <p:cNvSpPr txBox="1"/>
           <p:nvPr/>
         </p:nvSpPr>
@@ -5693,7 +5620,7 @@
       </p:sp>
       <p:sp>
         <p:nvSpPr>
-          <p:cNvPr id="17" name="TextBox 16"/>
+          <p:cNvPr id="16" name="TextBox 15"/>
           <p:cNvSpPr txBox="1"/>
           <p:nvPr/>
         </p:nvSpPr>
@@ -5728,7 +5655,7 @@
       </p:sp>
       <p:sp>
         <p:nvSpPr>
-          <p:cNvPr id="18" name="TextBox 17"/>
+          <p:cNvPr id="17" name="TextBox 16"/>
           <p:cNvSpPr txBox="1"/>
           <p:nvPr/>
         </p:nvSpPr>
@@ -5775,7 +5702,7 @@
               <p:cTn id="2" dur="indefinite" nodeType="mainSeq">
                 <p:childTnLst>
                   <p:par>
-                    <p:cTn id="3" presetID="10" presetClass="entr" presetSubtype="0" fill="hold" grpId="0" nodeType="clickEffect">
+                    <p:cTn id="3" presetID="22" presetClass="entr" presetSubtype="8" fill="hold" grpId="0" nodeType="clickEffect">
                       <p:stCondLst>
                         <p:cond delay="0"/>
                       </p:stCondLst>
@@ -5800,59 +5727,9 @@
                         </p:set>
                         <p:anim calcmode="lin" valueType="num">
                           <p:cBhvr additive="base">
-                            <p:cTn id="5" dur="300" fill="hold"/>
+                            <p:cTn id="5" dur="400" fill="hold"/>
                             <p:tgtEl>
                               <p:spTgt spid="7"/>
-                            </p:tgtEl>
-                            <p:attrNameLst>
-                              <p:attrName>style.opacity</p:attrName>
-                            </p:attrNameLst>
-                          </p:cBhvr>
-                          <p:tavLst>
-                            <p:tav tm="0">
-                              <p:val>
-                                <p:fltVal val="0"/>
-                              </p:val>
-                            </p:tav>
-                            <p:tav tm="100000">
-                              <p:val>
-                                <p:fltVal val="1"/>
-                              </p:val>
-                            </p:tav>
-                          </p:tavLst>
-                        </p:anim>
-                      </p:childTnLst>
-                    </p:cTn>
-                  </p:par>
-                  <p:par>
-                    <p:cTn id="6" presetID="22" presetClass="entr" presetSubtype="8" fill="hold" grpId="0" nodeType="clickEffect">
-                      <p:stCondLst>
-                        <p:cond delay="0"/>
-                      </p:stCondLst>
-                      <p:childTnLst>
-                        <p:set>
-                          <p:cBhvr>
-                            <p:cTn id="7" dur="1" fill="hold">
-                              <p:stCondLst>
-                                <p:cond delay="0"/>
-                              </p:stCondLst>
-                            </p:cTn>
-                            <p:tgtEl>
-                              <p:spTgt spid="8"/>
-                            </p:tgtEl>
-                            <p:attrNameLst>
-                              <p:attrName>style.visibility</p:attrName>
-                            </p:attrNameLst>
-                          </p:cBhvr>
-                          <p:to>
-                            <p:strVal val="visible"/>
-                          </p:to>
-                        </p:set>
-                        <p:anim calcmode="lin" valueType="num">
-                          <p:cBhvr additive="base">
-                            <p:cTn id="8" dur="400" fill="hold"/>
-                            <p:tgtEl>
-                              <p:spTgt spid="8"/>
                             </p:tgtEl>
                             <p:attrNameLst>
                               <p:attrName>ppt_w</p:attrName>
@@ -6917,7 +6794,7 @@
                 </a:solidFill>
                 <a:latin typeface="Montserrat"/>
               </a:rPr>
-              <a:t>Релиз v1.0.0</a:t>
+              <a:t>Релиз v1.1.0</a:t>
             </a:r>
           </a:p>
         </p:txBody>
@@ -11962,8 +11839,42 @@
         </p:nvSpPr>
         <p:spPr>
           <a:xfrm>
-            <a:off x="822960" y="1965960"/>
-            <a:ext cx="10545775" cy="457200"/>
+            <a:off x="822960" y="2286000"/>
+            <a:ext cx="3200400" cy="1097280"/>
+          </a:xfrm>
+          <a:prstGeom prst="rect">
+            <a:avLst/>
+          </a:prstGeom>
+          <a:noFill/>
+        </p:spPr>
+        <p:txBody>
+          <a:bodyPr wrap="square" anchor="b">
+            <a:spAutoFit/>
+          </a:bodyPr>
+          <a:lstStyle/>
+          <a:p>
+            <a:r>
+              <a:rPr sz="6000" b="1">
+                <a:solidFill>
+                  <a:srgbClr val="DC2626"/>
+                </a:solidFill>
+                <a:latin typeface="Tektur"/>
+              </a:rPr>
+              <a:t>80</a:t>
+            </a:r>
+          </a:p>
+        </p:txBody>
+      </p:sp>
+      <p:sp>
+        <p:nvSpPr>
+          <p:cNvPr id="6" name="TextBox 5"/>
+          <p:cNvSpPr txBox="1"/>
+          <p:nvPr/>
+        </p:nvSpPr>
+        <p:spPr>
+          <a:xfrm>
+            <a:off x="822960" y="3337560"/>
+            <a:ext cx="3200400" cy="365760"/>
           </a:xfrm>
           <a:prstGeom prst="rect">
             <a:avLst/>
@@ -11977,27 +11888,95 @@
           <a:lstStyle/>
           <a:p>
             <a:r>
-              <a:rPr sz="1400" b="0">
+              <a:rPr sz="1500" b="0">
                 <a:solidFill>
                   <a:srgbClr val="A8A29E"/>
                 </a:solidFill>
                 <a:latin typeface="Montserrat"/>
               </a:rPr>
-              <a:t>На корпусе уточнения. Отдельно проверено на реальном датасете: 45 + 45, precision 1.00</a:t>
-            </a:r>
-          </a:p>
-        </p:txBody>
-      </p:sp>
-      <p:sp>
-        <p:nvSpPr>
-          <p:cNvPr id="6" name="TextBox 5"/>
+              <a:t>контрпримеров в v1</a:t>
+            </a:r>
+          </a:p>
+        </p:txBody>
+      </p:sp>
+      <p:sp>
+        <p:nvSpPr>
+          <p:cNvPr id="7" name="TextBox 6"/>
           <p:cNvSpPr txBox="1"/>
           <p:nvPr/>
         </p:nvSpPr>
         <p:spPr>
           <a:xfrm>
-            <a:off x="822960" y="5394960"/>
-            <a:ext cx="10545775" cy="548640"/>
+            <a:off x="4114800" y="2286000"/>
+            <a:ext cx="822960" cy="1097280"/>
+          </a:xfrm>
+          <a:prstGeom prst="rect">
+            <a:avLst/>
+          </a:prstGeom>
+          <a:noFill/>
+        </p:spPr>
+        <p:txBody>
+          <a:bodyPr wrap="square" anchor="b">
+            <a:spAutoFit/>
+          </a:bodyPr>
+          <a:lstStyle/>
+          <a:p>
+            <a:r>
+              <a:rPr sz="4400" b="0">
+                <a:solidFill>
+                  <a:srgbClr val="7A7570"/>
+                </a:solidFill>
+                <a:latin typeface="Tektur"/>
+              </a:rPr>
+              <a:t>→</a:t>
+            </a:r>
+          </a:p>
+        </p:txBody>
+      </p:sp>
+      <p:sp>
+        <p:nvSpPr>
+          <p:cNvPr id="8" name="TextBox 7"/>
+          <p:cNvSpPr txBox="1"/>
+          <p:nvPr/>
+        </p:nvSpPr>
+        <p:spPr>
+          <a:xfrm>
+            <a:off x="4983480" y="2286000"/>
+            <a:ext cx="3200400" cy="1097280"/>
+          </a:xfrm>
+          <a:prstGeom prst="rect">
+            <a:avLst/>
+          </a:prstGeom>
+          <a:noFill/>
+        </p:spPr>
+        <p:txBody>
+          <a:bodyPr wrap="square" anchor="b">
+            <a:spAutoFit/>
+          </a:bodyPr>
+          <a:lstStyle/>
+          <a:p>
+            <a:r>
+              <a:rPr sz="6000" b="1">
+                <a:solidFill>
+                  <a:srgbClr val="16A34A"/>
+                </a:solidFill>
+                <a:latin typeface="Tektur"/>
+              </a:rPr>
+              <a:t>0</a:t>
+            </a:r>
+          </a:p>
+        </p:txBody>
+      </p:sp>
+      <p:sp>
+        <p:nvSpPr>
+          <p:cNvPr id="9" name="TextBox 8"/>
+          <p:cNvSpPr txBox="1"/>
+          <p:nvPr/>
+        </p:nvSpPr>
+        <p:spPr>
+          <a:xfrm>
+            <a:off x="4983480" y="3337560"/>
+            <a:ext cx="3200400" cy="365760"/>
           </a:xfrm>
           <a:prstGeom prst="rect">
             <a:avLst/>
@@ -12011,6 +11990,40 @@
           <a:lstStyle/>
           <a:p>
             <a:r>
+              <a:rPr sz="1500" b="0">
+                <a:solidFill>
+                  <a:srgbClr val="A8A29E"/>
+                </a:solidFill>
+                <a:latin typeface="Montserrat"/>
+              </a:rPr>
+              <a:t>контрпримеров в v2</a:t>
+            </a:r>
+          </a:p>
+        </p:txBody>
+      </p:sp>
+      <p:sp>
+        <p:nvSpPr>
+          <p:cNvPr id="10" name="TextBox 9"/>
+          <p:cNvSpPr txBox="1"/>
+          <p:nvPr/>
+        </p:nvSpPr>
+        <p:spPr>
+          <a:xfrm>
+            <a:off x="822960" y="5760720"/>
+            <a:ext cx="10545775" cy="548640"/>
+          </a:xfrm>
+          <a:prstGeom prst="rect">
+            <a:avLst/>
+          </a:prstGeom>
+          <a:noFill/>
+        </p:spPr>
+        <p:txBody>
+          <a:bodyPr wrap="square" anchor="t">
+            <a:spAutoFit/>
+          </a:bodyPr>
+          <a:lstStyle/>
+          <a:p>
+            <a:r>
               <a:rPr sz="1600" b="0">
                 <a:solidFill>
                   <a:srgbClr val="F4F1EC"/>
@@ -12024,13 +12037,13 @@
       </p:sp>
       <p:sp>
         <p:nvSpPr>
-          <p:cNvPr id="7" name="TextBox 6"/>
+          <p:cNvPr id="11" name="TextBox 10"/>
           <p:cNvSpPr txBox="1"/>
           <p:nvPr/>
         </p:nvSpPr>
         <p:spPr>
           <a:xfrm>
-            <a:off x="822960" y="2788920"/>
+            <a:off x="822960" y="3931920"/>
             <a:ext cx="914400" cy="640080"/>
           </a:xfrm>
           <a:prstGeom prst="rect">
@@ -12058,13 +12071,13 @@
       </p:sp>
       <p:sp>
         <p:nvSpPr>
-          <p:cNvPr id="8" name="Rectangle 7"/>
+          <p:cNvPr id="12" name="Rectangle 11"/>
           <p:cNvSpPr/>
           <p:nvPr/>
         </p:nvSpPr>
         <p:spPr>
           <a:xfrm>
-            <a:off x="1828800" y="2834640"/>
+            <a:off x="1828800" y="3977640"/>
             <a:ext cx="7436815" cy="548640"/>
           </a:xfrm>
           <a:prstGeom prst="rect">
@@ -12102,13 +12115,13 @@
       </p:sp>
       <p:sp>
         <p:nvSpPr>
-          <p:cNvPr id="9" name="Rectangle 8"/>
+          <p:cNvPr id="13" name="Rectangle 12"/>
           <p:cNvSpPr/>
           <p:nvPr/>
         </p:nvSpPr>
         <p:spPr>
           <a:xfrm>
-            <a:off x="1828800" y="2834640"/>
+            <a:off x="1828800" y="3977640"/>
             <a:ext cx="3197830" cy="548640"/>
           </a:xfrm>
           <a:prstGeom prst="rect">
@@ -12146,13 +12159,13 @@
       </p:sp>
       <p:sp>
         <p:nvSpPr>
-          <p:cNvPr id="10" name="TextBox 9"/>
+          <p:cNvPr id="14" name="TextBox 13"/>
           <p:cNvSpPr txBox="1"/>
           <p:nvPr/>
         </p:nvSpPr>
         <p:spPr>
           <a:xfrm>
-            <a:off x="9357055" y="2788920"/>
+            <a:off x="9357055" y="3931920"/>
             <a:ext cx="2011680" cy="640080"/>
           </a:xfrm>
           <a:prstGeom prst="rect">
@@ -12181,13 +12194,13 @@
       </p:sp>
       <p:sp>
         <p:nvSpPr>
-          <p:cNvPr id="11" name="TextBox 10"/>
+          <p:cNvPr id="15" name="TextBox 14"/>
           <p:cNvSpPr txBox="1"/>
           <p:nvPr/>
         </p:nvSpPr>
         <p:spPr>
           <a:xfrm>
-            <a:off x="822960" y="3977640"/>
+            <a:off x="822960" y="4800600"/>
             <a:ext cx="914400" cy="640080"/>
           </a:xfrm>
           <a:prstGeom prst="rect">
@@ -12215,13 +12228,13 @@
       </p:sp>
       <p:sp>
         <p:nvSpPr>
-          <p:cNvPr id="12" name="Rectangle 11"/>
+          <p:cNvPr id="16" name="Rectangle 15"/>
           <p:cNvSpPr/>
           <p:nvPr/>
         </p:nvSpPr>
         <p:spPr>
           <a:xfrm>
-            <a:off x="1828800" y="4023360"/>
+            <a:off x="1828800" y="4846320"/>
             <a:ext cx="7436815" cy="548640"/>
           </a:xfrm>
           <a:prstGeom prst="rect">
@@ -12259,13 +12272,13 @@
       </p:sp>
       <p:sp>
         <p:nvSpPr>
-          <p:cNvPr id="13" name="Rectangle 12"/>
+          <p:cNvPr id="17" name="Rectangle 16"/>
           <p:cNvSpPr/>
           <p:nvPr/>
         </p:nvSpPr>
         <p:spPr>
           <a:xfrm>
-            <a:off x="1828800" y="4023360"/>
+            <a:off x="1828800" y="4846320"/>
             <a:ext cx="7436815" cy="548640"/>
           </a:xfrm>
           <a:prstGeom prst="rect">
@@ -12303,13 +12316,13 @@
       </p:sp>
       <p:sp>
         <p:nvSpPr>
-          <p:cNvPr id="14" name="TextBox 13"/>
+          <p:cNvPr id="18" name="TextBox 17"/>
           <p:cNvSpPr txBox="1"/>
           <p:nvPr/>
         </p:nvSpPr>
         <p:spPr>
           <a:xfrm>
-            <a:off x="9357055" y="3977640"/>
+            <a:off x="9357055" y="4800600"/>
             <a:ext cx="2011680" cy="640080"/>
           </a:xfrm>
           <a:prstGeom prst="rect">
@@ -12338,7 +12351,7 @@
       </p:sp>
       <p:sp>
         <p:nvSpPr>
-          <p:cNvPr id="15" name="TextBox 14"/>
+          <p:cNvPr id="19" name="TextBox 18"/>
           <p:cNvSpPr txBox="1"/>
           <p:nvPr/>
         </p:nvSpPr>
@@ -12372,7 +12385,7 @@
       </p:sp>
       <p:sp>
         <p:nvSpPr>
-          <p:cNvPr id="16" name="TextBox 15"/>
+          <p:cNvPr id="20" name="TextBox 19"/>
           <p:cNvSpPr txBox="1"/>
           <p:nvPr/>
         </p:nvSpPr>
@@ -12407,7 +12420,7 @@
       </p:sp>
       <p:sp>
         <p:nvSpPr>
-          <p:cNvPr id="17" name="TextBox 16"/>
+          <p:cNvPr id="21" name="TextBox 20"/>
           <p:cNvSpPr txBox="1"/>
           <p:nvPr/>
         </p:nvSpPr>
@@ -12467,7 +12480,7 @@
                               </p:stCondLst>
                             </p:cTn>
                             <p:tgtEl>
-                              <p:spTgt spid="9"/>
+                              <p:spTgt spid="13"/>
                             </p:tgtEl>
                             <p:attrNameLst>
                               <p:attrName>style.visibility</p:attrName>
@@ -12481,7 +12494,7 @@
                           <p:cBhvr additive="base">
                             <p:cTn id="5" dur="300" fill="hold"/>
                             <p:tgtEl>
-                              <p:spTgt spid="9"/>
+                              <p:spTgt spid="13"/>
                             </p:tgtEl>
                             <p:attrNameLst>
                               <p:attrName>style.opacity</p:attrName>
@@ -12517,7 +12530,7 @@
                               </p:stCondLst>
                             </p:cTn>
                             <p:tgtEl>
-                              <p:spTgt spid="13"/>
+                              <p:spTgt spid="17"/>
                             </p:tgtEl>
                             <p:attrNameLst>
                               <p:attrName>style.visibility</p:attrName>
@@ -12531,7 +12544,7 @@
                           <p:cBhvr additive="base">
                             <p:cTn id="8" dur="300" fill="hold"/>
                             <p:tgtEl>
-                              <p:spTgt spid="13"/>
+                              <p:spTgt spid="17"/>
                             </p:tgtEl>
                             <p:attrNameLst>
                               <p:attrName>style.opacity</p:attrName>

</xml_diff>